<commit_message>
Round 2: symmetric journey lines, P3/P4-style question column, outcome cards
Co-Authored-By: Claude Fable 5 <noreply@anthropic.com>
Claude-Session: https://claude.ai/code/session_01A3Z3HHfQP1XqLkWjeuhpsJ
</commit_message>
<xml_diff>
--- a/proposal/20260721_TU_Three_Pager_vDraft.pptx
+++ b/proposal/20260721_TU_Three_Pager_vDraft.pptx
@@ -16788,7 +16788,7 @@
         </p:nvSpPr>
         <p:spPr>
           <a:xfrm>
-            <a:off x="904875" y="4138283"/>
+            <a:off x="904875" y="4430891"/>
             <a:ext cx="3857625" cy="190500"/>
           </a:xfrm>
           <a:prstGeom prst="rightArrow">
@@ -16868,7 +16868,7 @@
         </p:nvSpPr>
         <p:spPr>
           <a:xfrm rot="19700478">
-            <a:off x="4594567" y="3753143"/>
+            <a:off x="4594567" y="4045751"/>
             <a:ext cx="1428750" cy="190500"/>
           </a:xfrm>
           <a:prstGeom prst="rightArrow">
@@ -17339,7 +17339,7 @@
         </p:nvSpPr>
         <p:spPr>
           <a:xfrm>
-            <a:off x="554736" y="3620564"/>
+            <a:off x="554736" y="3913172"/>
             <a:ext cx="2857500" cy="285750"/>
           </a:xfrm>
           <a:prstGeom prst="rect">
@@ -17397,7 +17397,7 @@
         </p:nvSpPr>
         <p:spPr>
           <a:xfrm>
-            <a:off x="933450" y="4087289"/>
+            <a:off x="933450" y="4379897"/>
             <a:ext cx="266700" cy="266700"/>
           </a:xfrm>
           <a:prstGeom prst="ellipse">
@@ -17437,7 +17437,7 @@
         </p:nvSpPr>
         <p:spPr>
           <a:xfrm>
-            <a:off x="2524125" y="4087289"/>
+            <a:off x="2524125" y="4379897"/>
             <a:ext cx="266700" cy="266700"/>
           </a:xfrm>
           <a:prstGeom prst="ellipse">
@@ -17477,7 +17477,7 @@
         </p:nvSpPr>
         <p:spPr>
           <a:xfrm>
-            <a:off x="4219575" y="4087289"/>
+            <a:off x="4219575" y="4379897"/>
             <a:ext cx="266700" cy="266700"/>
           </a:xfrm>
           <a:prstGeom prst="ellipse">
@@ -17517,7 +17517,7 @@
         </p:nvSpPr>
         <p:spPr>
           <a:xfrm>
-            <a:off x="666522" y="4392089"/>
+            <a:off x="666522" y="4684697"/>
             <a:ext cx="796693" cy="215444"/>
           </a:xfrm>
           <a:prstGeom prst="rect">
@@ -17594,7 +17594,7 @@
         </p:nvSpPr>
         <p:spPr>
           <a:xfrm>
-            <a:off x="2057400" y="4392089"/>
+            <a:off x="2057400" y="4684697"/>
             <a:ext cx="1285875" cy="228600"/>
           </a:xfrm>
           <a:prstGeom prst="rect">
@@ -17652,7 +17652,7 @@
         </p:nvSpPr>
         <p:spPr>
           <a:xfrm>
-            <a:off x="3667125" y="4392089"/>
+            <a:off x="3667125" y="4684697"/>
             <a:ext cx="1428750" cy="400050"/>
           </a:xfrm>
           <a:prstGeom prst="rect">
@@ -17718,7 +17718,7 @@
         </p:nvSpPr>
         <p:spPr>
           <a:xfrm>
-            <a:off x="3876674" y="4854606"/>
+            <a:off x="3876674" y="5147214"/>
             <a:ext cx="1000125" cy="209550"/>
           </a:xfrm>
           <a:prstGeom prst="rect">
@@ -19328,7 +19328,7 @@
         </p:nvSpPr>
         <p:spPr>
           <a:xfrm>
-            <a:off x="5570935" y="2649014"/>
+            <a:off x="5570935" y="2795318"/>
             <a:ext cx="1162050" cy="1162050"/>
           </a:xfrm>
           <a:prstGeom prst="ellipse">
@@ -19419,22 +19419,13 @@
               </a:lnSpc>
             </a:pPr>
             <a:r>
-              <a:rPr sz="1200" b="0">
-                <a:solidFill>
-                  <a:srgbClr val="000000"/>
-                </a:solidFill>
-                <a:latin typeface="Arial"/>
-              </a:rPr>
-              <a:t>TU has evolved from credit bureau, to product company, to </a:t>
-            </a:r>
-            <a:r>
               <a:rPr sz="1200" b="1">
                 <a:solidFill>
                   <a:srgbClr val="000000"/>
                 </a:solidFill>
                 <a:latin typeface="Arial"/>
               </a:rPr>
-              <a:t>platform organization</a:t>
+              <a:t>The business has transformed</a:t>
             </a:r>
             <a:r>
               <a:rPr sz="1200" b="0">
@@ -19443,8 +19434,38 @@
                 </a:solidFill>
                 <a:latin typeface="Arial"/>
               </a:rPr>
-              <a:t> — and it has embarked on its AI journey, </a:t>
+              <a:t> — from credit bureau, to product company, to platform company: thin products on thick platforms</a:t>
             </a:r>
+          </a:p>
+        </p:txBody>
+      </p:sp>
+      <p:sp>
+        <p:nvSpPr>
+          <p:cNvPr id="56" name="TextBox 55"/>
+          <p:cNvSpPr txBox="1"/>
+          <p:nvPr/>
+        </p:nvSpPr>
+        <p:spPr>
+          <a:xfrm>
+            <a:off x="557784" y="3547872"/>
+            <a:ext cx="4892040" cy="402336"/>
+          </a:xfrm>
+          <a:prstGeom prst="rect">
+            <a:avLst/>
+          </a:prstGeom>
+          <a:noFill/>
+        </p:spPr>
+        <p:txBody>
+          <a:bodyPr wrap="square" lIns="0" rIns="0" tIns="0" bIns="0">
+            <a:spAutoFit/>
+          </a:bodyPr>
+          <a:lstStyle/>
+          <a:p>
+            <a:pPr>
+              <a:lnSpc>
+                <a:spcPct val="105000"/>
+              </a:lnSpc>
+            </a:pPr>
             <a:r>
               <a:rPr sz="1200" b="1">
                 <a:solidFill>
@@ -19452,7 +19473,7 @@
                 </a:solidFill>
                 <a:latin typeface="Arial"/>
               </a:rPr>
-              <a:t>albeit still early</a:t>
+              <a:t>The AI journey is younger</a:t>
             </a:r>
             <a:r>
               <a:rPr sz="1200" b="0">
@@ -19461,7 +19482,7 @@
                 </a:solidFill>
                 <a:latin typeface="Arial"/>
               </a:rPr>
-              <a:t>:</a:t>
+              <a:t> — from curiosity to pilots, and now to choosing the priority domains: still early, with the big bets ahead</a:t>
             </a:r>
           </a:p>
         </p:txBody>
@@ -21919,8 +21940,8 @@
         </p:nvSpPr>
         <p:spPr>
           <a:xfrm>
-            <a:off x="5184980" y="1802704"/>
-            <a:ext cx="784078" cy="369332"/>
+            <a:off x="5184980" y="1801368"/>
+            <a:ext cx="1143000" cy="548640"/>
           </a:xfrm>
           <a:prstGeom prst="rect">
             <a:avLst/>
@@ -21941,50 +21962,7 @@
                 </a:solidFill>
                 <a:latin typeface="Arial"/>
               </a:rPr>
-              <a:t>ORG HYGIENE</a:t>
-            </a:r>
-          </a:p>
-        </p:txBody>
-      </p:sp>
-      <p:sp>
-        <p:nvSpPr>
-          <p:cNvPr id="19" name="TextBox 18"/>
-          <p:cNvSpPr txBox="1">
-            <a:spLocks/>
-          </p:cNvSpPr>
-          <p:nvPr/>
-        </p:nvSpPr>
-        <p:spPr>
-          <a:xfrm>
-            <a:off x="6430956" y="1802704"/>
-            <a:ext cx="5203257" cy="430887"/>
-          </a:xfrm>
-          <a:prstGeom prst="rect">
-            <a:avLst/>
-          </a:prstGeom>
-          <a:noFill/>
-        </p:spPr>
-        <p:txBody>
-          <a:bodyPr wrap="square" lIns="0" tIns="0" rIns="0" bIns="0" anchor="t">
-            <a:spAutoFit/>
-          </a:bodyPr>
-          <a:lstStyle/>
-          <a:p>
-            <a:pPr marL="171450" indent="-171450" algn="l">
-              <a:lnSpc>
-                <a:spcPct val="100000"/>
-              </a:lnSpc>
-              <a:buFont typeface="Arial" panose="020B0604020202020204" pitchFamily="34" charset="0"/>
-              <a:buChar char="•"/>
-            </a:pPr>
-            <a:r>
-              <a:rPr sz="1400" b="0" i="0" dirty="0">
-                <a:solidFill>
-                  <a:srgbClr val="000000"/>
-                </a:solidFill>
-                <a:latin typeface="Arial"/>
-              </a:rPr>
-              <a:t>What does a right-sized TU look like — optimal spans, layers, leadership density — and the value at stake?</a:t>
+              <a:t>A. ORG HYGIENE</a:t>
             </a:r>
           </a:p>
         </p:txBody>
@@ -22009,8 +21987,8 @@
         </p:nvCxnSpPr>
         <p:spPr>
           <a:xfrm>
-            <a:off x="6282545" y="1802704"/>
-            <a:ext cx="0" cy="429768"/>
+            <a:off x="6282545" y="1801368"/>
+            <a:ext cx="0" cy="365760"/>
           </a:xfrm>
           <a:prstGeom prst="straightConnector1">
             <a:avLst/>
@@ -22040,14 +22018,66 @@
       </p:cxnSp>
       <p:sp>
         <p:nvSpPr>
-          <p:cNvPr id="25" name="TextBox 24"/>
+          <p:cNvPr id="19" name="TextBox 18"/>
+          <p:cNvSpPr txBox="1">
+            <a:spLocks/>
+          </p:cNvSpPr>
+          <p:nvPr/>
+        </p:nvSpPr>
+        <p:spPr>
+          <a:xfrm>
+            <a:off x="6430956" y="1801368"/>
+            <a:ext cx="5203257" cy="365760"/>
+          </a:xfrm>
+          <a:prstGeom prst="rect">
+            <a:avLst/>
+          </a:prstGeom>
+          <a:noFill/>
+        </p:spPr>
+        <p:txBody>
+          <a:bodyPr wrap="square" lIns="0" tIns="0" rIns="0" bIns="0" anchor="t">
+            <a:spAutoFit/>
+          </a:bodyPr>
+          <a:lstStyle/>
+          <a:p>
+            <a:pPr marL="171450" indent="-171450" algn="l">
+              <a:lnSpc>
+                <a:spcPct val="100000"/>
+              </a:lnSpc>
+              <a:buFont typeface="Arial" panose="020B0604020202020204" pitchFamily="34" charset="0"/>
+              <a:buChar char="•"/>
+            </a:pPr>
+            <a:r>
+              <a:rPr sz="1100" b="1" i="0" dirty="0">
+                <a:solidFill>
+                  <a:srgbClr val="000000"/>
+                </a:solidFill>
+                <a:latin typeface="Arial"/>
+              </a:rPr>
+              <a:t>What would a right-sized TU look like</a:t>
+            </a:r>
+            <a:r>
+              <a:rPr sz="1100" b="0" i="0" dirty="0">
+                <a:solidFill>
+                  <a:srgbClr val="000000"/>
+                </a:solidFill>
+                <a:latin typeface="Arial"/>
+              </a:rPr>
+              <a:t> — and what value would optimal spans, layers, and leadership density unlock?</a:t>
+            </a:r>
+          </a:p>
+        </p:txBody>
+      </p:sp>
+      <p:sp>
+        <p:nvSpPr>
+          <p:cNvPr id="17" name="TextBox 16"/>
           <p:cNvSpPr txBox="1"/>
           <p:nvPr/>
         </p:nvSpPr>
         <p:spPr>
           <a:xfrm>
-            <a:off x="5184980" y="2286000"/>
-            <a:ext cx="1016064" cy="553998"/>
+            <a:off x="5184980" y="2276856"/>
+            <a:ext cx="1143000" cy="777240"/>
           </a:xfrm>
           <a:prstGeom prst="rect">
             <a:avLst/>
@@ -22068,214 +22098,17 @@
                 </a:solidFill>
                 <a:latin typeface="Arial"/>
               </a:rPr>
-              <a:t>FUTURE-READY WORKFORCE</a:t>
+              <a:t>B. PLATFORM ORG OF THE FUTURE</a:t>
             </a:r>
           </a:p>
         </p:txBody>
       </p:sp>
-      <p:grpSp>
-        <p:nvGrpSpPr>
-          <p:cNvPr id="22" name="Group 21">
+      <p:cxnSp>
+        <p:nvCxnSpPr>
+          <p:cNvPr id="54" name="LineBasicImpact 54">
             <a:extLst>
               <a:ext uri="{FF2B5EF4-FFF2-40B4-BE49-F238E27FC236}">
-                <a16:creationId xmlns:a16="http://schemas.microsoft.com/office/drawing/2014/main" id="{3B27236C-7421-1ED7-6993-7A2330EA10F4}"/>
-              </a:ext>
-            </a:extLst>
-          </p:cNvPr>
-          <p:cNvGrpSpPr>
-            <a:grpSpLocks/>
-          </p:cNvGrpSpPr>
-          <p:nvPr/>
-        </p:nvGrpSpPr>
-        <p:grpSpPr>
-          <a:xfrm>
-            <a:off x="6430956" y="2286000"/>
-            <a:ext cx="5203257" cy="1354566"/>
-            <a:chOff x="6430956" y="2941826"/>
-            <a:chExt cx="5203257" cy="1354566"/>
-          </a:xfrm>
-        </p:grpSpPr>
-        <p:sp>
-          <p:nvSpPr>
-            <p:cNvPr id="27" name="TextBox 26"/>
-            <p:cNvSpPr txBox="1">
-              <a:spLocks/>
-            </p:cNvSpPr>
-            <p:nvPr/>
-          </p:nvSpPr>
-          <p:spPr>
-            <a:xfrm>
-              <a:off x="6430956" y="2941826"/>
-              <a:ext cx="5203257" cy="430887"/>
-            </a:xfrm>
-            <a:prstGeom prst="rect">
-              <a:avLst/>
-            </a:prstGeom>
-            <a:noFill/>
-          </p:spPr>
-          <p:txBody>
-            <a:bodyPr wrap="square" lIns="0" tIns="0" rIns="0" bIns="0" anchor="t">
-              <a:spAutoFit/>
-            </a:bodyPr>
-            <a:lstStyle/>
-            <a:p>
-              <a:pPr marL="171450" indent="-171450" algn="l">
-                <a:lnSpc>
-                  <a:spcPct val="100000"/>
-                </a:lnSpc>
-                <a:buFont typeface="Arial" panose="020B0604020202020204" pitchFamily="34" charset="0"/>
-                <a:buChar char="•"/>
-              </a:pPr>
-              <a:r>
-                <a:rPr sz="1400" b="0" i="0" dirty="0">
-                  <a:solidFill>
-                    <a:srgbClr val="000000"/>
-                  </a:solidFill>
-                  <a:latin typeface="Arial"/>
-                </a:rPr>
-                <a:t>How will AI and automation change talent demand over the next 3–5 years?</a:t>
-              </a:r>
-            </a:p>
-          </p:txBody>
-        </p:sp>
-        <p:sp>
-          <p:nvSpPr>
-            <p:cNvPr id="28" name="TextBox 27"/>
-            <p:cNvSpPr txBox="1">
-              <a:spLocks/>
-            </p:cNvSpPr>
-            <p:nvPr/>
-          </p:nvSpPr>
-          <p:spPr>
-            <a:xfrm>
-              <a:off x="6430956" y="3511387"/>
-              <a:ext cx="5203257" cy="430887"/>
-            </a:xfrm>
-            <a:prstGeom prst="rect">
-              <a:avLst/>
-            </a:prstGeom>
-            <a:noFill/>
-          </p:spPr>
-          <p:txBody>
-            <a:bodyPr wrap="square" lIns="0" tIns="0" rIns="0" bIns="0" anchor="t">
-              <a:spAutoFit/>
-            </a:bodyPr>
-            <a:lstStyle/>
-            <a:p>
-              <a:pPr marL="171450" indent="-171450" algn="l">
-                <a:lnSpc>
-                  <a:spcPct val="100000"/>
-                </a:lnSpc>
-                <a:buFont typeface="Arial" panose="020B0604020202020204" pitchFamily="34" charset="0"/>
-                <a:buChar char="•"/>
-              </a:pPr>
-              <a:r>
-                <a:rPr sz="1400" b="0" i="0" dirty="0">
-                  <a:solidFill>
-                    <a:srgbClr val="000000"/>
-                  </a:solidFill>
-                  <a:latin typeface="Arial"/>
-                </a:rPr>
-                <a:t>What size, shape, and skills</a:t>
-              </a:r>
-              <a:r>
-                <a:rPr lang="en-US" sz="1400" dirty="0">
-                  <a:solidFill>
-                    <a:srgbClr val="000000"/>
-                  </a:solidFill>
-                  <a:latin typeface="Arial"/>
-                </a:rPr>
-                <a:t>? W</a:t>
-              </a:r>
-              <a:r>
-                <a:rPr sz="1400" b="0" i="0" dirty="0">
-                  <a:solidFill>
-                    <a:srgbClr val="000000"/>
-                  </a:solidFill>
-                  <a:latin typeface="Arial"/>
-                </a:rPr>
-                <a:t>hich roles are reshaped, replaced, or net-new</a:t>
-              </a:r>
-              <a:r>
-                <a:rPr lang="en-US" sz="1400" dirty="0">
-                  <a:solidFill>
-                    <a:srgbClr val="000000"/>
-                  </a:solidFill>
-                  <a:latin typeface="Arial"/>
-                </a:rPr>
-                <a:t>? B</a:t>
-              </a:r>
-              <a:r>
-                <a:rPr sz="1400" b="0" i="0" dirty="0">
-                  <a:solidFill>
-                    <a:srgbClr val="000000"/>
-                  </a:solidFill>
-                  <a:latin typeface="Arial"/>
-                </a:rPr>
-                <a:t>uilt vs. bought?</a:t>
-              </a:r>
-            </a:p>
-          </p:txBody>
-        </p:sp>
-        <p:sp>
-          <p:nvSpPr>
-            <p:cNvPr id="29" name="TextBox 28"/>
-            <p:cNvSpPr txBox="1">
-              <a:spLocks/>
-            </p:cNvSpPr>
-            <p:nvPr/>
-          </p:nvSpPr>
-          <p:spPr>
-            <a:xfrm>
-              <a:off x="6430956" y="4080948"/>
-              <a:ext cx="5203257" cy="215444"/>
-            </a:xfrm>
-            <a:prstGeom prst="rect">
-              <a:avLst/>
-            </a:prstGeom>
-            <a:noFill/>
-          </p:spPr>
-          <p:txBody>
-            <a:bodyPr wrap="square" lIns="0" tIns="0" rIns="0" bIns="0" anchor="t">
-              <a:spAutoFit/>
-            </a:bodyPr>
-            <a:lstStyle/>
-            <a:p>
-              <a:pPr marL="171450" indent="-171450" algn="l">
-                <a:lnSpc>
-                  <a:spcPct val="100000"/>
-                </a:lnSpc>
-                <a:buFont typeface="Arial" panose="020B0604020202020204" pitchFamily="34" charset="0"/>
-                <a:buChar char="•"/>
-              </a:pPr>
-              <a:r>
-                <a:rPr lang="en-US" sz="1400" b="0" i="0" dirty="0">
-                  <a:solidFill>
-                    <a:srgbClr val="000000"/>
-                  </a:solidFill>
-                  <a:latin typeface="Arial"/>
-                </a:rPr>
-                <a:t>W</a:t>
-              </a:r>
-              <a:r>
-                <a:rPr sz="1400" b="0" i="0" dirty="0">
-                  <a:solidFill>
-                    <a:srgbClr val="000000"/>
-                  </a:solidFill>
-                  <a:latin typeface="Arial"/>
-                </a:rPr>
-                <a:t>hat is the value case and the mobilization plan to capture it?</a:t>
-              </a:r>
-            </a:p>
-          </p:txBody>
-        </p:sp>
-      </p:grpSp>
-      <p:cxnSp>
-        <p:nvCxnSpPr>
-          <p:cNvPr id="59" name="LineBasicImpact 54">
-            <a:extLst>
-              <a:ext uri="{FF2B5EF4-FFF2-40B4-BE49-F238E27FC236}">
-                <a16:creationId xmlns:a16="http://schemas.microsoft.com/office/drawing/2014/main" id="{F281C4E1-204F-CC4C-4676-3847379EF709}"/>
+                <a16:creationId xmlns:a16="http://schemas.microsoft.com/office/drawing/2014/main" id="{1BAEDC8C-7A5B-6C3B-4369-6F78188BB1E8}"/>
               </a:ext>
             </a:extLst>
           </p:cNvPr>
@@ -22284,14 +22117,14 @@
           </p:cNvCxnSpPr>
           <p:nvPr>
             <p:custDataLst>
-              <p:tags r:id="rId6"/>
+              <p:tags r:id="rId5"/>
             </p:custDataLst>
           </p:nvPr>
         </p:nvCxnSpPr>
         <p:spPr>
           <a:xfrm>
-            <a:off x="6282545" y="2286000"/>
-            <a:ext cx="0" cy="1354566"/>
+            <a:off x="6282545" y="2276856"/>
+            <a:ext cx="0" cy="1572768"/>
           </a:xfrm>
           <a:prstGeom prst="straightConnector1">
             <a:avLst/>
@@ -22321,42 +22154,7 @@
       </p:cxnSp>
       <p:sp>
         <p:nvSpPr>
-          <p:cNvPr id="21" name="TextBox 20"/>
-          <p:cNvSpPr txBox="1"/>
-          <p:nvPr/>
-        </p:nvSpPr>
-        <p:spPr>
-          <a:xfrm>
-            <a:off x="5184980" y="3694176"/>
-            <a:ext cx="1203190" cy="553998"/>
-          </a:xfrm>
-          <a:prstGeom prst="rect">
-            <a:avLst/>
-          </a:prstGeom>
-          <a:noFill/>
-        </p:spPr>
-        <p:txBody>
-          <a:bodyPr wrap="square" lIns="0" tIns="0" rIns="0" bIns="0" anchor="t">
-            <a:spAutoFit/>
-          </a:bodyPr>
-          <a:lstStyle/>
-          <a:p>
-            <a:pPr algn="l"/>
-            <a:r>
-              <a:rPr sz="1200" b="1" i="0">
-                <a:solidFill>
-                  <a:srgbClr val="2251FF"/>
-                </a:solidFill>
-                <a:latin typeface="Arial"/>
-              </a:rPr>
-              <a:t>PLATFORM ORG OF THE FUTURE</a:t>
-            </a:r>
-          </a:p>
-        </p:txBody>
-      </p:sp>
-      <p:sp>
-        <p:nvSpPr>
-          <p:cNvPr id="23" name="TextBox 22"/>
+          <p:cNvPr id="19" name="TextBox 18"/>
           <p:cNvSpPr txBox="1">
             <a:spLocks/>
           </p:cNvSpPr>
@@ -22364,8 +22162,8 @@
         </p:nvSpPr>
         <p:spPr>
           <a:xfrm>
-            <a:off x="6430956" y="3694176"/>
-            <a:ext cx="5203257" cy="640080"/>
+            <a:off x="6430956" y="2276856"/>
+            <a:ext cx="5203257" cy="548640"/>
           </a:xfrm>
           <a:prstGeom prst="rect">
             <a:avLst/>
@@ -22386,26 +22184,29 @@
               <a:buChar char="•"/>
             </a:pPr>
             <a:r>
-              <a:rPr sz="1400" b="0" i="0" dirty="0">
+              <a:rPr sz="1100" b="1" i="0" dirty="0">
                 <a:solidFill>
                   <a:srgbClr val="000000"/>
                 </a:solidFill>
                 <a:latin typeface="Arial"/>
               </a:rPr>
-              <a:t>Which archetypes do true platform orgs follow — a central platform division (e.g., Atlassian, Salesforce) or federated services (e.g., AWS) — and which fits TU?</a:t>
+              <a:t>Which archetypes do true platform orgs follow</a:t>
             </a:r>
-            <a:endParaRPr sz="1400" b="0" i="0" dirty="0">
-              <a:solidFill>
-                <a:srgbClr val="000000"/>
-              </a:solidFill>
-              <a:latin typeface="Arial"/>
-            </a:endParaRPr>
+            <a:r>
+              <a:rPr sz="1100" b="0" i="0" dirty="0">
+                <a:solidFill>
+                  <a:srgbClr val="000000"/>
+                </a:solidFill>
+                <a:latin typeface="Arial"/>
+              </a:rPr>
+              <a:t> — a central platform division (e.g., Atlassian, Salesforce) or federated services (e.g., AWS) — and which fits TU?</a:t>
+            </a:r>
           </a:p>
         </p:txBody>
       </p:sp>
       <p:sp>
         <p:nvSpPr>
-          <p:cNvPr id="24" name="TextBox 23"/>
+          <p:cNvPr id="19" name="TextBox 18"/>
           <p:cNvSpPr txBox="1">
             <a:spLocks/>
           </p:cNvSpPr>
@@ -22413,8 +22214,8 @@
         </p:nvSpPr>
         <p:spPr>
           <a:xfrm>
-            <a:off x="6430956" y="4443984"/>
-            <a:ext cx="5203257" cy="640080"/>
+            <a:off x="6430956" y="2880360"/>
+            <a:ext cx="5203257" cy="548640"/>
           </a:xfrm>
           <a:prstGeom prst="rect">
             <a:avLst/>
@@ -22435,29 +22236,119 @@
               <a:buChar char="•"/>
             </a:pPr>
             <a:r>
-              <a:rPr sz="1400" b="0" i="0" dirty="0">
+              <a:rPr sz="1100" b="1" i="0" dirty="0">
                 <a:solidFill>
                   <a:srgbClr val="000000"/>
                 </a:solidFill>
                 <a:latin typeface="Arial"/>
               </a:rPr>
-              <a:t>What should be the size and composition of the platform and product engineering teams — and where should key roles reside (e.g., Platform PM, Data Science / Analytics, UI/UX)?</a:t>
+              <a:t>What size and composition for the platform and product engineering teams</a:t>
             </a:r>
-            <a:endParaRPr sz="1400" b="0" i="0" dirty="0">
-              <a:solidFill>
-                <a:srgbClr val="000000"/>
-              </a:solidFill>
-              <a:latin typeface="Arial"/>
-            </a:endParaRPr>
+            <a:r>
+              <a:rPr sz="1100" b="0" i="0" dirty="0">
+                <a:solidFill>
+                  <a:srgbClr val="000000"/>
+                </a:solidFill>
+                <a:latin typeface="Arial"/>
+              </a:rPr>
+              <a:t> — and where should key roles reside (e.g., Platform PM, Data Science / Analytics, UI/UX)?</a:t>
+            </a:r>
+          </a:p>
+        </p:txBody>
+      </p:sp>
+      <p:sp>
+        <p:nvSpPr>
+          <p:cNvPr id="19" name="TextBox 18"/>
+          <p:cNvSpPr txBox="1">
+            <a:spLocks/>
+          </p:cNvSpPr>
+          <p:nvPr/>
+        </p:nvSpPr>
+        <p:spPr>
+          <a:xfrm>
+            <a:off x="6430956" y="3483864"/>
+            <a:ext cx="5203257" cy="365760"/>
+          </a:xfrm>
+          <a:prstGeom prst="rect">
+            <a:avLst/>
+          </a:prstGeom>
+          <a:noFill/>
+        </p:spPr>
+        <p:txBody>
+          <a:bodyPr wrap="square" lIns="0" tIns="0" rIns="0" bIns="0" anchor="t">
+            <a:spAutoFit/>
+          </a:bodyPr>
+          <a:lstStyle/>
+          <a:p>
+            <a:pPr marL="171450" indent="-171450" algn="l">
+              <a:lnSpc>
+                <a:spcPct val="100000"/>
+              </a:lnSpc>
+              <a:buFont typeface="Arial" panose="020B0604020202020204" pitchFamily="34" charset="0"/>
+              <a:buChar char="•"/>
+            </a:pPr>
+            <a:r>
+              <a:rPr sz="1100" b="1" i="0" dirty="0">
+                <a:solidFill>
+                  <a:srgbClr val="000000"/>
+                </a:solidFill>
+                <a:latin typeface="Arial"/>
+              </a:rPr>
+              <a:t>What are the core design choices</a:t>
+            </a:r>
+            <a:r>
+              <a:rPr sz="1100" b="0" i="0" dirty="0">
+                <a:solidFill>
+                  <a:srgbClr val="000000"/>
+                </a:solidFill>
+                <a:latin typeface="Arial"/>
+              </a:rPr>
+              <a:t> — US vs. international P&amp;L, regional vs. global layers — and what must TU believe?</a:t>
+            </a:r>
+          </a:p>
+        </p:txBody>
+      </p:sp>
+      <p:sp>
+        <p:nvSpPr>
+          <p:cNvPr id="17" name="TextBox 16"/>
+          <p:cNvSpPr txBox="1"/>
+          <p:nvPr/>
+        </p:nvSpPr>
+        <p:spPr>
+          <a:xfrm>
+            <a:off x="5184980" y="3977639"/>
+            <a:ext cx="1143000" cy="777240"/>
+          </a:xfrm>
+          <a:prstGeom prst="rect">
+            <a:avLst/>
+          </a:prstGeom>
+          <a:noFill/>
+        </p:spPr>
+        <p:txBody>
+          <a:bodyPr wrap="square" lIns="0" tIns="0" rIns="0" bIns="0" anchor="t">
+            <a:spAutoFit/>
+          </a:bodyPr>
+          <a:lstStyle/>
+          <a:p>
+            <a:pPr algn="l"/>
+            <a:r>
+              <a:rPr sz="1200" b="1" i="0" dirty="0">
+                <a:solidFill>
+                  <a:srgbClr val="2251FF"/>
+                </a:solidFill>
+                <a:latin typeface="Arial"/>
+              </a:rPr>
+              <a:t>C. FUTURE-READY WORKFORCE</a:t>
+            </a:r>
           </a:p>
         </p:txBody>
       </p:sp>
       <p:cxnSp>
         <p:nvCxnSpPr>
-          <p:cNvPr id="63" name="LineBasicImpact 54">
+          <p:cNvPr id="54" name="LineBasicImpact 54">
             <a:extLst>
               <a:ext uri="{FF2B5EF4-FFF2-40B4-BE49-F238E27FC236}">
-                <a16:creationId xmlns:a16="http://schemas.microsoft.com/office/drawing/2014/main" id="{C9B1AFEC-01F4-7664-D18C-CA2379218227}"/>
+                <a16:creationId xmlns:a16="http://schemas.microsoft.com/office/drawing/2014/main" id="{1BAEDC8C-7A5B-6C3B-4369-6F78188BB1E8}"/>
               </a:ext>
             </a:extLst>
           </p:cNvPr>
@@ -22466,14 +22357,14 @@
           </p:cNvCxnSpPr>
           <p:nvPr>
             <p:custDataLst>
-              <p:tags r:id="rId7"/>
+              <p:tags r:id="rId5"/>
             </p:custDataLst>
           </p:nvPr>
         </p:nvCxnSpPr>
         <p:spPr>
           <a:xfrm>
-            <a:off x="6282545" y="3694176"/>
-            <a:ext cx="0" cy="1929384"/>
+            <a:off x="6282545" y="3977639"/>
+            <a:ext cx="0" cy="996696"/>
           </a:xfrm>
           <a:prstGeom prst="straightConnector1">
             <a:avLst/>
@@ -22503,42 +22394,7 @@
       </p:cxnSp>
       <p:sp>
         <p:nvSpPr>
-          <p:cNvPr id="33" name="TextBox 32"/>
-          <p:cNvSpPr txBox="1"/>
-          <p:nvPr/>
-        </p:nvSpPr>
-        <p:spPr>
-          <a:xfrm>
-            <a:off x="5184980" y="6143751"/>
-            <a:ext cx="722762" cy="184666"/>
-          </a:xfrm>
-          <a:prstGeom prst="rect">
-            <a:avLst/>
-          </a:prstGeom>
-          <a:noFill/>
-        </p:spPr>
-        <p:txBody>
-          <a:bodyPr wrap="none" lIns="0" tIns="0" rIns="0" bIns="0" anchor="t">
-            <a:spAutoFit/>
-          </a:bodyPr>
-          <a:lstStyle/>
-          <a:p>
-            <a:pPr algn="l"/>
-            <a:r>
-              <a:rPr sz="1200" b="1" i="0">
-                <a:solidFill>
-                  <a:srgbClr val="2251FF"/>
-                </a:solidFill>
-                <a:latin typeface="Arial"/>
-              </a:rPr>
-              <a:t>CULTURE</a:t>
-            </a:r>
-          </a:p>
-        </p:txBody>
-      </p:sp>
-      <p:sp>
-        <p:nvSpPr>
-          <p:cNvPr id="35" name="TextBox 34"/>
+          <p:cNvPr id="19" name="TextBox 18"/>
           <p:cNvSpPr txBox="1">
             <a:spLocks/>
           </p:cNvSpPr>
@@ -22546,8 +22402,8 @@
         </p:nvSpPr>
         <p:spPr>
           <a:xfrm>
-            <a:off x="6430956" y="6143751"/>
-            <a:ext cx="5203257" cy="353943"/>
+            <a:off x="6430956" y="3977639"/>
+            <a:ext cx="5203257" cy="365760"/>
           </a:xfrm>
           <a:prstGeom prst="rect">
             <a:avLst/>
@@ -22556,7 +22412,7 @@
         </p:spPr>
         <p:txBody>
           <a:bodyPr wrap="square" lIns="0" tIns="0" rIns="0" bIns="0" anchor="t">
-            <a:noAutofit/>
+            <a:spAutoFit/>
           </a:bodyPr>
           <a:lstStyle/>
           <a:p>
@@ -22568,32 +22424,171 @@
               <a:buChar char="•"/>
             </a:pPr>
             <a:r>
-              <a:rPr lang="en-US" sz="1400" i="0" dirty="0">
+              <a:rPr sz="1100" b="1" i="0" dirty="0">
                 <a:solidFill>
                   <a:srgbClr val="000000"/>
                 </a:solidFill>
                 <a:latin typeface="Arial"/>
               </a:rPr>
-              <a:t>What </a:t>
+              <a:t>How will AI change talent demand</a:t>
             </a:r>
             <a:r>
-              <a:rPr sz="1400" b="0" i="0" dirty="0">
+              <a:rPr sz="1100" b="0" i="0" dirty="0">
                 <a:solidFill>
                   <a:srgbClr val="000000"/>
                 </a:solidFill>
                 <a:latin typeface="Arial"/>
               </a:rPr>
-              <a:t>mindset and behavior shifts are needed — and is there change capacity to absorb them?</a:t>
+              <a:t> over the next 3–5 years, function by function?</a:t>
+            </a:r>
+          </a:p>
+        </p:txBody>
+      </p:sp>
+      <p:sp>
+        <p:nvSpPr>
+          <p:cNvPr id="19" name="TextBox 18"/>
+          <p:cNvSpPr txBox="1">
+            <a:spLocks/>
+          </p:cNvSpPr>
+          <p:nvPr/>
+        </p:nvSpPr>
+        <p:spPr>
+          <a:xfrm>
+            <a:off x="6430956" y="4398264"/>
+            <a:ext cx="5203257" cy="365760"/>
+          </a:xfrm>
+          <a:prstGeom prst="rect">
+            <a:avLst/>
+          </a:prstGeom>
+          <a:noFill/>
+        </p:spPr>
+        <p:txBody>
+          <a:bodyPr wrap="square" lIns="0" tIns="0" rIns="0" bIns="0" anchor="t">
+            <a:spAutoFit/>
+          </a:bodyPr>
+          <a:lstStyle/>
+          <a:p>
+            <a:pPr marL="171450" indent="-171450" algn="l">
+              <a:lnSpc>
+                <a:spcPct val="100000"/>
+              </a:lnSpc>
+              <a:buFont typeface="Arial" panose="020B0604020202020204" pitchFamily="34" charset="0"/>
+              <a:buChar char="•"/>
+            </a:pPr>
+            <a:r>
+              <a:rPr sz="1100" b="1" i="0" dirty="0">
+                <a:solidFill>
+                  <a:srgbClr val="000000"/>
+                </a:solidFill>
+                <a:latin typeface="Arial"/>
+              </a:rPr>
+              <a:t>What size, shape, and skills</a:t>
+            </a:r>
+            <a:r>
+              <a:rPr sz="1100" b="0" i="0" dirty="0">
+                <a:solidFill>
+                  <a:srgbClr val="000000"/>
+                </a:solidFill>
+                <a:latin typeface="Arial"/>
+              </a:rPr>
+              <a:t> — which roles are reshaped, replaced, or net-new; built vs. bought?</a:t>
+            </a:r>
+          </a:p>
+        </p:txBody>
+      </p:sp>
+      <p:sp>
+        <p:nvSpPr>
+          <p:cNvPr id="19" name="TextBox 18"/>
+          <p:cNvSpPr txBox="1">
+            <a:spLocks/>
+          </p:cNvSpPr>
+          <p:nvPr/>
+        </p:nvSpPr>
+        <p:spPr>
+          <a:xfrm>
+            <a:off x="6430956" y="4818888"/>
+            <a:ext cx="5203257" cy="192024"/>
+          </a:xfrm>
+          <a:prstGeom prst="rect">
+            <a:avLst/>
+          </a:prstGeom>
+          <a:noFill/>
+        </p:spPr>
+        <p:txBody>
+          <a:bodyPr wrap="square" lIns="0" tIns="0" rIns="0" bIns="0" anchor="t">
+            <a:spAutoFit/>
+          </a:bodyPr>
+          <a:lstStyle/>
+          <a:p>
+            <a:pPr marL="171450" indent="-171450" algn="l">
+              <a:lnSpc>
+                <a:spcPct val="100000"/>
+              </a:lnSpc>
+              <a:buFont typeface="Arial" panose="020B0604020202020204" pitchFamily="34" charset="0"/>
+              <a:buChar char="•"/>
+            </a:pPr>
+            <a:r>
+              <a:rPr sz="1100" b="1" i="0" dirty="0">
+                <a:solidFill>
+                  <a:srgbClr val="000000"/>
+                </a:solidFill>
+                <a:latin typeface="Arial"/>
+              </a:rPr>
+              <a:t>What is the value case</a:t>
+            </a:r>
+            <a:r>
+              <a:rPr sz="1100" b="0" i="0" dirty="0">
+                <a:solidFill>
+                  <a:srgbClr val="000000"/>
+                </a:solidFill>
+                <a:latin typeface="Arial"/>
+              </a:rPr>
+              <a:t> — and the mobilization plan to capture it?</a:t>
+            </a:r>
+          </a:p>
+        </p:txBody>
+      </p:sp>
+      <p:sp>
+        <p:nvSpPr>
+          <p:cNvPr id="17" name="TextBox 16"/>
+          <p:cNvSpPr txBox="1"/>
+          <p:nvPr/>
+        </p:nvSpPr>
+        <p:spPr>
+          <a:xfrm>
+            <a:off x="5184980" y="5138928"/>
+            <a:ext cx="1143000" cy="777240"/>
+          </a:xfrm>
+          <a:prstGeom prst="rect">
+            <a:avLst/>
+          </a:prstGeom>
+          <a:noFill/>
+        </p:spPr>
+        <p:txBody>
+          <a:bodyPr wrap="square" lIns="0" tIns="0" rIns="0" bIns="0" anchor="t">
+            <a:spAutoFit/>
+          </a:bodyPr>
+          <a:lstStyle/>
+          <a:p>
+            <a:pPr algn="l"/>
+            <a:r>
+              <a:rPr sz="1200" b="1" i="0" dirty="0">
+                <a:solidFill>
+                  <a:srgbClr val="2251FF"/>
+                </a:solidFill>
+                <a:latin typeface="Arial"/>
+              </a:rPr>
+              <a:t>D. GLOBAL LOCATION STRATEGY</a:t>
             </a:r>
           </a:p>
         </p:txBody>
       </p:sp>
       <p:cxnSp>
         <p:nvCxnSpPr>
-          <p:cNvPr id="64" name="LineBasicImpact 54">
+          <p:cNvPr id="54" name="LineBasicImpact 54">
             <a:extLst>
               <a:ext uri="{FF2B5EF4-FFF2-40B4-BE49-F238E27FC236}">
-                <a16:creationId xmlns:a16="http://schemas.microsoft.com/office/drawing/2014/main" id="{3187CA57-4EC7-AB71-D0E7-EE9C232EF910}"/>
+                <a16:creationId xmlns:a16="http://schemas.microsoft.com/office/drawing/2014/main" id="{1BAEDC8C-7A5B-6C3B-4369-6F78188BB1E8}"/>
               </a:ext>
             </a:extLst>
           </p:cNvPr>
@@ -22602,14 +22597,14 @@
           </p:cNvCxnSpPr>
           <p:nvPr>
             <p:custDataLst>
-              <p:tags r:id="rId8"/>
+              <p:tags r:id="rId5"/>
             </p:custDataLst>
           </p:nvPr>
         </p:nvCxnSpPr>
         <p:spPr>
           <a:xfrm>
-            <a:off x="6282545" y="6143751"/>
-            <a:ext cx="0" cy="353943"/>
+            <a:off x="6282545" y="5138928"/>
+            <a:ext cx="0" cy="557784"/>
           </a:xfrm>
           <a:prstGeom prst="straightConnector1">
             <a:avLst/>
@@ -22639,14 +22634,118 @@
       </p:cxnSp>
       <p:sp>
         <p:nvSpPr>
-          <p:cNvPr id="30" name="TextBox 29"/>
+          <p:cNvPr id="19" name="TextBox 18"/>
+          <p:cNvSpPr txBox="1">
+            <a:spLocks/>
+          </p:cNvSpPr>
+          <p:nvPr/>
+        </p:nvSpPr>
+        <p:spPr>
+          <a:xfrm>
+            <a:off x="6430956" y="5138928"/>
+            <a:ext cx="5203257" cy="192024"/>
+          </a:xfrm>
+          <a:prstGeom prst="rect">
+            <a:avLst/>
+          </a:prstGeom>
+          <a:noFill/>
+        </p:spPr>
+        <p:txBody>
+          <a:bodyPr wrap="square" lIns="0" tIns="0" rIns="0" bIns="0" anchor="t">
+            <a:spAutoFit/>
+          </a:bodyPr>
+          <a:lstStyle/>
+          <a:p>
+            <a:pPr marL="171450" indent="-171450" algn="l">
+              <a:lnSpc>
+                <a:spcPct val="100000"/>
+              </a:lnSpc>
+              <a:buFont typeface="Arial" panose="020B0604020202020204" pitchFamily="34" charset="0"/>
+              <a:buChar char="•"/>
+            </a:pPr>
+            <a:r>
+              <a:rPr sz="1100" b="1" i="0" dirty="0">
+                <a:solidFill>
+                  <a:srgbClr val="000000"/>
+                </a:solidFill>
+                <a:latin typeface="Arial"/>
+              </a:rPr>
+              <a:t>Which roles sit where</a:t>
+            </a:r>
+            <a:r>
+              <a:rPr sz="1100" b="0" i="0" dirty="0">
+                <a:solidFill>
+                  <a:srgbClr val="000000"/>
+                </a:solidFill>
+                <a:latin typeface="Arial"/>
+              </a:rPr>
+              <a:t> — and what moves now vs. later?</a:t>
+            </a:r>
+          </a:p>
+        </p:txBody>
+      </p:sp>
+      <p:sp>
+        <p:nvSpPr>
+          <p:cNvPr id="19" name="TextBox 18"/>
+          <p:cNvSpPr txBox="1">
+            <a:spLocks/>
+          </p:cNvSpPr>
+          <p:nvPr/>
+        </p:nvSpPr>
+        <p:spPr>
+          <a:xfrm>
+            <a:off x="6430956" y="5385816"/>
+            <a:ext cx="5203257" cy="365760"/>
+          </a:xfrm>
+          <a:prstGeom prst="rect">
+            <a:avLst/>
+          </a:prstGeom>
+          <a:noFill/>
+        </p:spPr>
+        <p:txBody>
+          <a:bodyPr wrap="square" lIns="0" tIns="0" rIns="0" bIns="0" anchor="t">
+            <a:spAutoFit/>
+          </a:bodyPr>
+          <a:lstStyle/>
+          <a:p>
+            <a:pPr marL="171450" indent="-171450" algn="l">
+              <a:lnSpc>
+                <a:spcPct val="100000"/>
+              </a:lnSpc>
+              <a:buFont typeface="Arial" panose="020B0604020202020204" pitchFamily="34" charset="0"/>
+              <a:buChar char="•"/>
+            </a:pPr>
+            <a:r>
+              <a:rPr sz="1100" b="1" i="0" dirty="0">
+                <a:solidFill>
+                  <a:srgbClr val="000000"/>
+                </a:solidFill>
+                <a:latin typeface="Arial"/>
+              </a:rPr>
+              <a:t>Where will TU access AI-era talent</a:t>
+            </a:r>
+            <a:r>
+              <a:rPr sz="1100" b="0" i="0" dirty="0">
+                <a:solidFill>
+                  <a:srgbClr val="000000"/>
+                </a:solidFill>
+                <a:latin typeface="Arial"/>
+              </a:rPr>
+              <a:t> — and what must its global hubs become?</a:t>
+            </a:r>
+          </a:p>
+        </p:txBody>
+      </p:sp>
+      <p:sp>
+        <p:nvSpPr>
+          <p:cNvPr id="17" name="TextBox 16"/>
           <p:cNvSpPr txBox="1"/>
           <p:nvPr/>
         </p:nvSpPr>
         <p:spPr>
           <a:xfrm>
-            <a:off x="5184980" y="5733288"/>
-            <a:ext cx="1090330" cy="369332"/>
+            <a:off x="5184980" y="5824728"/>
+            <a:ext cx="1143000" cy="548640"/>
           </a:xfrm>
           <a:prstGeom prst="rect">
             <a:avLst/>
@@ -22667,60 +22766,17 @@
                 </a:solidFill>
                 <a:latin typeface="Arial"/>
               </a:rPr>
-              <a:t>LOCATION STRATEGY</a:t>
-            </a:r>
-          </a:p>
-        </p:txBody>
-      </p:sp>
-      <p:sp>
-        <p:nvSpPr>
-          <p:cNvPr id="32" name="TextBox 31"/>
-          <p:cNvSpPr txBox="1">
-            <a:spLocks/>
-          </p:cNvSpPr>
-          <p:nvPr/>
-        </p:nvSpPr>
-        <p:spPr>
-          <a:xfrm>
-            <a:off x="6430956" y="5733288"/>
-            <a:ext cx="5203257" cy="215444"/>
-          </a:xfrm>
-          <a:prstGeom prst="rect">
-            <a:avLst/>
-          </a:prstGeom>
-          <a:noFill/>
-        </p:spPr>
-        <p:txBody>
-          <a:bodyPr wrap="square" lIns="0" tIns="0" rIns="0" bIns="0" anchor="t">
-            <a:spAutoFit/>
-          </a:bodyPr>
-          <a:lstStyle/>
-          <a:p>
-            <a:pPr marL="171450" indent="-171450" algn="l">
-              <a:lnSpc>
-                <a:spcPct val="100000"/>
-              </a:lnSpc>
-              <a:buFont typeface="Arial" panose="020B0604020202020204" pitchFamily="34" charset="0"/>
-              <a:buChar char="•"/>
-            </a:pPr>
-            <a:r>
-              <a:rPr sz="1400" b="0" i="0" dirty="0">
-                <a:solidFill>
-                  <a:srgbClr val="000000"/>
-                </a:solidFill>
-                <a:latin typeface="Arial"/>
-              </a:rPr>
-              <a:t>Which roles sit where and what moves now vs. later?</a:t>
+              <a:t>E. CULTURE AND CHANGE</a:t>
             </a:r>
           </a:p>
         </p:txBody>
       </p:sp>
       <p:cxnSp>
         <p:nvCxnSpPr>
-          <p:cNvPr id="65" name="LineBasicImpact 54">
+          <p:cNvPr id="54" name="LineBasicImpact 54">
             <a:extLst>
               <a:ext uri="{FF2B5EF4-FFF2-40B4-BE49-F238E27FC236}">
-                <a16:creationId xmlns:a16="http://schemas.microsoft.com/office/drawing/2014/main" id="{EAC89B31-6FA4-C276-1F5C-77E86143B3B1}"/>
+                <a16:creationId xmlns:a16="http://schemas.microsoft.com/office/drawing/2014/main" id="{1BAEDC8C-7A5B-6C3B-4369-6F78188BB1E8}"/>
               </a:ext>
             </a:extLst>
           </p:cNvPr>
@@ -22729,14 +22785,14 @@
           </p:cNvCxnSpPr>
           <p:nvPr>
             <p:custDataLst>
-              <p:tags r:id="rId9"/>
+              <p:tags r:id="rId5"/>
             </p:custDataLst>
           </p:nvPr>
         </p:nvCxnSpPr>
         <p:spPr>
           <a:xfrm>
-            <a:off x="6282545" y="5733288"/>
-            <a:ext cx="0" cy="219456"/>
+            <a:off x="6282545" y="5824728"/>
+            <a:ext cx="0" cy="594360"/>
           </a:xfrm>
           <a:prstGeom prst="straightConnector1">
             <a:avLst/>
@@ -22766,7 +22822,7 @@
       </p:cxnSp>
       <p:sp>
         <p:nvSpPr>
-          <p:cNvPr id="24" name="TextBox 23"/>
+          <p:cNvPr id="19" name="TextBox 18"/>
           <p:cNvSpPr txBox="1">
             <a:spLocks/>
           </p:cNvSpPr>
@@ -22774,8 +22830,8 @@
         </p:nvSpPr>
         <p:spPr>
           <a:xfrm>
-            <a:off x="6430956" y="5193792"/>
-            <a:ext cx="5203257" cy="429768"/>
+            <a:off x="6430956" y="5824728"/>
+            <a:ext cx="5203257" cy="365760"/>
           </a:xfrm>
           <a:prstGeom prst="rect">
             <a:avLst/>
@@ -22796,20 +22852,75 @@
               <a:buChar char="•"/>
             </a:pPr>
             <a:r>
-              <a:rPr sz="1400" b="0" i="0" dirty="0">
+              <a:rPr sz="1100" b="1" i="0" dirty="0">
                 <a:solidFill>
                   <a:srgbClr val="000000"/>
                 </a:solidFill>
                 <a:latin typeface="Arial"/>
               </a:rPr>
-              <a:t>What are the core design choices — US vs. international P&amp;L, regional vs. global layers — and what must TU believe?</a:t>
+              <a:t>What mindset and behavior shifts</a:t>
             </a:r>
-            <a:endParaRPr sz="1400" b="0" i="0" dirty="0">
-              <a:solidFill>
-                <a:srgbClr val="000000"/>
-              </a:solidFill>
-              <a:latin typeface="Arial"/>
-            </a:endParaRPr>
+            <a:r>
+              <a:rPr sz="1100" b="0" i="0" dirty="0">
+                <a:solidFill>
+                  <a:srgbClr val="000000"/>
+                </a:solidFill>
+                <a:latin typeface="Arial"/>
+              </a:rPr>
+              <a:t> does the new organization demand?</a:t>
+            </a:r>
+          </a:p>
+        </p:txBody>
+      </p:sp>
+      <p:sp>
+        <p:nvSpPr>
+          <p:cNvPr id="19" name="TextBox 18"/>
+          <p:cNvSpPr txBox="1">
+            <a:spLocks/>
+          </p:cNvSpPr>
+          <p:nvPr/>
+        </p:nvSpPr>
+        <p:spPr>
+          <a:xfrm>
+            <a:off x="6430956" y="6227064"/>
+            <a:ext cx="5203257" cy="192024"/>
+          </a:xfrm>
+          <a:prstGeom prst="rect">
+            <a:avLst/>
+          </a:prstGeom>
+          <a:noFill/>
+        </p:spPr>
+        <p:txBody>
+          <a:bodyPr wrap="square" lIns="0" tIns="0" rIns="0" bIns="0" anchor="t">
+            <a:spAutoFit/>
+          </a:bodyPr>
+          <a:lstStyle/>
+          <a:p>
+            <a:pPr marL="171450" indent="-171450" algn="l">
+              <a:lnSpc>
+                <a:spcPct val="100000"/>
+              </a:lnSpc>
+              <a:buFont typeface="Arial" panose="020B0604020202020204" pitchFamily="34" charset="0"/>
+              <a:buChar char="•"/>
+            </a:pPr>
+            <a:r>
+              <a:rPr sz="1100" b="1" i="0" dirty="0">
+                <a:solidFill>
+                  <a:srgbClr val="000000"/>
+                </a:solidFill>
+                <a:latin typeface="Arial"/>
+              </a:rPr>
+              <a:t>Does TU have the change capacity</a:t>
+            </a:r>
+            <a:r>
+              <a:rPr sz="1100" b="0" i="0" dirty="0">
+                <a:solidFill>
+                  <a:srgbClr val="000000"/>
+                </a:solidFill>
+                <a:latin typeface="Arial"/>
+              </a:rPr>
+              <a:t> — and how do we build it?</a:t>
+            </a:r>
           </a:p>
         </p:txBody>
       </p:sp>
@@ -26048,7 +26159,7 @@
         </p:nvSpPr>
         <p:spPr>
           <a:xfrm>
-            <a:off x="557784" y="4798588"/>
+            <a:off x="557784" y="4700016"/>
             <a:ext cx="7315200" cy="164592"/>
           </a:xfrm>
           <a:prstGeom prst="rect">
@@ -26101,126 +26212,14 @@
       </p:sp>
       <p:sp>
         <p:nvSpPr>
-          <p:cNvPr id="60" name="TextBox 59"/>
-          <p:cNvSpPr txBox="1"/>
-          <p:nvPr/>
-        </p:nvSpPr>
-        <p:spPr>
-          <a:xfrm>
-            <a:off x="557784" y="4999756"/>
-            <a:ext cx="11076431" cy="523220"/>
-          </a:xfrm>
-          <a:prstGeom prst="rect">
-            <a:avLst/>
-          </a:prstGeom>
-          <a:noFill/>
-        </p:spPr>
-        <p:txBody>
-          <a:bodyPr wrap="square" lIns="0" tIns="0" rIns="0" bIns="0" anchor="t">
-            <a:spAutoFit/>
-          </a:bodyPr>
-          <a:lstStyle/>
-          <a:p>
-            <a:pPr marL="0" marR="0" lvl="0" indent="0" algn="l" defTabSz="914400" rtl="0" eaLnBrk="1" fontAlgn="auto" latinLnBrk="0" hangingPunct="1">
-              <a:lnSpc>
-                <a:spcPct val="100000"/>
-              </a:lnSpc>
-              <a:spcBef>
-                <a:spcPts val="0"/>
-              </a:spcBef>
-              <a:spcAft>
-                <a:spcPts val="0"/>
-              </a:spcAft>
-              <a:buClrTx/>
-              <a:buSzTx/>
-              <a:buFontTx/>
-              <a:buNone/>
-              <a:tabLst/>
-              <a:defRPr/>
-            </a:pPr>
-            <a:r>
-              <a:rPr kumimoji="0" sz="1050" b="1" i="0" u="none" strike="noStrike" kern="1200" cap="none" spc="0" normalizeH="0" baseline="0" noProof="0" dirty="0">
-                <a:ln>
-                  <a:noFill/>
-                </a:ln>
-                <a:solidFill>
-                  <a:srgbClr val="061F79"/>
-                </a:solidFill>
-                <a:effectLst/>
-                <a:uLnTx/>
-                <a:uFillTx/>
-                <a:latin typeface="Arial"/>
-                <a:ea typeface="+mn-ea"/>
-                <a:cs typeface="+mn-cs"/>
-              </a:rPr>
-              <a:t>By week 12:  </a:t>
-            </a:r>
-            <a:r>
-              <a:rPr kumimoji="0" sz="1050" b="1" i="0" u="none" strike="noStrike" kern="1200" cap="none" spc="0" normalizeH="0" baseline="0" noProof="0" dirty="0">
-                <a:ln>
-                  <a:noFill/>
-                </a:ln>
-                <a:solidFill>
-                  <a:srgbClr val="000000"/>
-                </a:solidFill>
-                <a:effectLst/>
-                <a:uLnTx/>
-                <a:uFillTx/>
-                <a:latin typeface="Arial"/>
-                <a:ea typeface="+mn-ea"/>
-                <a:cs typeface="+mn-cs"/>
-              </a:rPr>
-              <a:t>prioritized domain portfolio and value-backed roadmap  ·  target org blueprint and strategic workforce plan  ·  location and talent roadmap, with a 90-day mobilization plan</a:t>
-            </a:r>
-          </a:p>
-          <a:p>
-            <a:pPr marL="0" marR="0" lvl="0" indent="0" algn="l" defTabSz="914400" rtl="0" eaLnBrk="1" fontAlgn="auto" latinLnBrk="0" hangingPunct="1">
-              <a:lnSpc>
-                <a:spcPct val="100000"/>
-              </a:lnSpc>
-              <a:spcBef>
-                <a:spcPts val="300"/>
-              </a:spcBef>
-              <a:spcAft>
-                <a:spcPts val="0"/>
-              </a:spcAft>
-              <a:buClrTx/>
-              <a:buSzTx/>
-              <a:buFontTx/>
-              <a:buNone/>
-              <a:tabLst/>
-              <a:defRPr/>
-            </a:pPr>
-            <a:r>
-              <a:rPr kumimoji="0" sz="1050" b="1" i="0" u="none" strike="noStrike" kern="1200" cap="none" spc="0" normalizeH="0" baseline="0" noProof="0" dirty="0">
-                <a:ln>
-                  <a:noFill/>
-                </a:ln>
-                <a:solidFill>
-                  <a:srgbClr val="63666A"/>
-                </a:solidFill>
-                <a:effectLst/>
-                <a:uLnTx/>
-                <a:uFillTx/>
-                <a:latin typeface="Arial"/>
-                <a:ea typeface="+mn-ea"/>
-                <a:cs typeface="+mn-cs"/>
-              </a:rPr>
-              <a:t>Joint TU–McKinsey team; leadership checkpoints at weeks 2, 7, and 12</a:t>
-            </a:r>
-          </a:p>
-        </p:txBody>
-      </p:sp>
-      <p:sp>
-        <p:nvSpPr>
           <p:cNvPr id="61" name="Rounded Rectangle 60"/>
           <p:cNvSpPr/>
           <p:nvPr/>
         </p:nvSpPr>
         <p:spPr>
           <a:xfrm>
-            <a:off x="557784" y="5596128"/>
-            <a:ext cx="11082528" cy="777240"/>
+            <a:off x="557784" y="5815584"/>
+            <a:ext cx="11082528" cy="621792"/>
           </a:xfrm>
           <a:prstGeom prst="roundRect">
             <a:avLst>
@@ -26295,8 +26294,8 @@
         </p:nvSpPr>
         <p:spPr>
           <a:xfrm>
-            <a:off x="868680" y="5799396"/>
-            <a:ext cx="10469880" cy="379848"/>
+            <a:off x="868680" y="5888736"/>
+            <a:ext cx="10469880" cy="475488"/>
           </a:xfrm>
           <a:prstGeom prst="rect">
             <a:avLst/>
@@ -26474,6 +26473,350 @@
           </a:prstGeom>
         </p:spPr>
       </p:pic>
+      <p:sp>
+        <p:nvSpPr>
+          <p:cNvPr id="73" name="TextBox 72"/>
+          <p:cNvSpPr txBox="1"/>
+          <p:nvPr/>
+        </p:nvSpPr>
+        <p:spPr>
+          <a:xfrm>
+            <a:off x="557784" y="4974336"/>
+            <a:ext cx="1444752" cy="731520"/>
+          </a:xfrm>
+          <a:prstGeom prst="rect">
+            <a:avLst/>
+          </a:prstGeom>
+          <a:noFill/>
+        </p:spPr>
+        <p:txBody>
+          <a:bodyPr wrap="square" lIns="0" rIns="0" tIns="0" bIns="0">
+            <a:spAutoFit/>
+          </a:bodyPr>
+          <a:lstStyle/>
+          <a:p>
+            <a:r>
+              <a:rPr sz="1200" b="1">
+                <a:solidFill>
+                  <a:srgbClr val="061F79"/>
+                </a:solidFill>
+                <a:latin typeface="Arial"/>
+              </a:rPr>
+              <a:t>By week 12</a:t>
+            </a:r>
+          </a:p>
+          <a:p>
+            <a:pPr>
+              <a:spcBef>
+                <a:spcPts val="400"/>
+              </a:spcBef>
+            </a:pPr>
+            <a:r>
+              <a:rPr sz="850" b="0">
+                <a:solidFill>
+                  <a:srgbClr val="63666A"/>
+                </a:solidFill>
+                <a:latin typeface="Arial"/>
+              </a:rPr>
+              <a:t>Joint TU–McKinsey team; checkpoints at wk 2, 7, 12</a:t>
+            </a:r>
+          </a:p>
+        </p:txBody>
+      </p:sp>
+      <p:sp>
+        <p:nvSpPr>
+          <p:cNvPr id="74" name="Rounded Rectangle 73"/>
+          <p:cNvSpPr/>
+          <p:nvPr/>
+        </p:nvSpPr>
+        <p:spPr>
+          <a:xfrm>
+            <a:off x="2103120" y="4974336"/>
+            <a:ext cx="3072384" cy="713232"/>
+          </a:xfrm>
+          <a:prstGeom prst="roundRect">
+            <a:avLst>
+              <a:gd name="adj" fmla="val 12000"/>
+            </a:avLst>
+          </a:prstGeom>
+          <a:solidFill>
+            <a:srgbClr val="F0F4FF"/>
+          </a:solidFill>
+          <a:ln w="12700">
+            <a:solidFill>
+              <a:srgbClr val="2251FF"/>
+            </a:solidFill>
+          </a:ln>
+          <a:effectLst/>
+        </p:spPr>
+        <p:style>
+          <a:lnRef idx="1">
+            <a:schemeClr val="accent1"/>
+          </a:lnRef>
+          <a:fillRef idx="3">
+            <a:schemeClr val="accent1"/>
+          </a:fillRef>
+          <a:effectRef idx="2">
+            <a:schemeClr val="accent1"/>
+          </a:effectRef>
+          <a:fontRef idx="minor">
+            <a:schemeClr val="lt1"/>
+          </a:fontRef>
+        </p:style>
+        <p:txBody>
+          <a:bodyPr rtlCol="0" anchor="ctr"/>
+          <a:lstStyle/>
+          <a:p>
+            <a:pPr algn="ctr"/>
+          </a:p>
+        </p:txBody>
+      </p:sp>
+      <p:sp>
+        <p:nvSpPr>
+          <p:cNvPr id="75" name="TextBox 74"/>
+          <p:cNvSpPr txBox="1"/>
+          <p:nvPr/>
+        </p:nvSpPr>
+        <p:spPr>
+          <a:xfrm>
+            <a:off x="2249424" y="5065776"/>
+            <a:ext cx="2779776" cy="548640"/>
+          </a:xfrm>
+          <a:prstGeom prst="rect">
+            <a:avLst/>
+          </a:prstGeom>
+          <a:noFill/>
+        </p:spPr>
+        <p:txBody>
+          <a:bodyPr wrap="square" lIns="0" rIns="0" tIns="0" bIns="0">
+            <a:spAutoFit/>
+          </a:bodyPr>
+          <a:lstStyle/>
+          <a:p>
+            <a:r>
+              <a:rPr sz="1150" b="1">
+                <a:solidFill>
+                  <a:srgbClr val="061F79"/>
+                </a:solidFill>
+                <a:latin typeface="Arial"/>
+              </a:rPr>
+              <a:t>Prioritized domain portfolio</a:t>
+            </a:r>
+          </a:p>
+          <a:p>
+            <a:pPr>
+              <a:spcBef>
+                <a:spcPts val="300"/>
+              </a:spcBef>
+            </a:pPr>
+            <a:r>
+              <a:rPr sz="1000" b="0">
+                <a:solidFill>
+                  <a:srgbClr val="000000"/>
+                </a:solidFill>
+                <a:latin typeface="Arial"/>
+              </a:rPr>
+              <a:t>2–3 big bets, value-backed and sequenced</a:t>
+            </a:r>
+          </a:p>
+        </p:txBody>
+      </p:sp>
+      <p:sp>
+        <p:nvSpPr>
+          <p:cNvPr id="76" name="Rounded Rectangle 75"/>
+          <p:cNvSpPr/>
+          <p:nvPr/>
+        </p:nvSpPr>
+        <p:spPr>
+          <a:xfrm>
+            <a:off x="5330952" y="4974336"/>
+            <a:ext cx="3072384" cy="713232"/>
+          </a:xfrm>
+          <a:prstGeom prst="roundRect">
+            <a:avLst>
+              <a:gd name="adj" fmla="val 12000"/>
+            </a:avLst>
+          </a:prstGeom>
+          <a:solidFill>
+            <a:srgbClr val="F0F4FF"/>
+          </a:solidFill>
+          <a:ln w="12700">
+            <a:solidFill>
+              <a:srgbClr val="2251FF"/>
+            </a:solidFill>
+          </a:ln>
+          <a:effectLst/>
+        </p:spPr>
+        <p:style>
+          <a:lnRef idx="1">
+            <a:schemeClr val="accent1"/>
+          </a:lnRef>
+          <a:fillRef idx="3">
+            <a:schemeClr val="accent1"/>
+          </a:fillRef>
+          <a:effectRef idx="2">
+            <a:schemeClr val="accent1"/>
+          </a:effectRef>
+          <a:fontRef idx="minor">
+            <a:schemeClr val="lt1"/>
+          </a:fontRef>
+        </p:style>
+        <p:txBody>
+          <a:bodyPr rtlCol="0" anchor="ctr"/>
+          <a:lstStyle/>
+          <a:p>
+            <a:pPr algn="ctr"/>
+          </a:p>
+        </p:txBody>
+      </p:sp>
+      <p:sp>
+        <p:nvSpPr>
+          <p:cNvPr id="77" name="TextBox 76"/>
+          <p:cNvSpPr txBox="1"/>
+          <p:nvPr/>
+        </p:nvSpPr>
+        <p:spPr>
+          <a:xfrm>
+            <a:off x="5477256" y="5065776"/>
+            <a:ext cx="2779776" cy="548640"/>
+          </a:xfrm>
+          <a:prstGeom prst="rect">
+            <a:avLst/>
+          </a:prstGeom>
+          <a:noFill/>
+        </p:spPr>
+        <p:txBody>
+          <a:bodyPr wrap="square" lIns="0" rIns="0" tIns="0" bIns="0">
+            <a:spAutoFit/>
+          </a:bodyPr>
+          <a:lstStyle/>
+          <a:p>
+            <a:r>
+              <a:rPr sz="1150" b="1">
+                <a:solidFill>
+                  <a:srgbClr val="061F79"/>
+                </a:solidFill>
+                <a:latin typeface="Arial"/>
+              </a:rPr>
+              <a:t>Target org blueprint</a:t>
+            </a:r>
+          </a:p>
+          <a:p>
+            <a:pPr>
+              <a:spcBef>
+                <a:spcPts val="300"/>
+              </a:spcBef>
+            </a:pPr>
+            <a:r>
+              <a:rPr sz="1000" b="0">
+                <a:solidFill>
+                  <a:srgbClr val="000000"/>
+                </a:solidFill>
+                <a:latin typeface="Arial"/>
+              </a:rPr>
+              <a:t>Platform-era structure and strategic workforce plan</a:t>
+            </a:r>
+          </a:p>
+        </p:txBody>
+      </p:sp>
+      <p:sp>
+        <p:nvSpPr>
+          <p:cNvPr id="78" name="Rounded Rectangle 77"/>
+          <p:cNvSpPr/>
+          <p:nvPr/>
+        </p:nvSpPr>
+        <p:spPr>
+          <a:xfrm>
+            <a:off x="8558784" y="4974336"/>
+            <a:ext cx="3072384" cy="713232"/>
+          </a:xfrm>
+          <a:prstGeom prst="roundRect">
+            <a:avLst>
+              <a:gd name="adj" fmla="val 12000"/>
+            </a:avLst>
+          </a:prstGeom>
+          <a:solidFill>
+            <a:srgbClr val="F0F4FF"/>
+          </a:solidFill>
+          <a:ln w="12700">
+            <a:solidFill>
+              <a:srgbClr val="2251FF"/>
+            </a:solidFill>
+          </a:ln>
+          <a:effectLst/>
+        </p:spPr>
+        <p:style>
+          <a:lnRef idx="1">
+            <a:schemeClr val="accent1"/>
+          </a:lnRef>
+          <a:fillRef idx="3">
+            <a:schemeClr val="accent1"/>
+          </a:fillRef>
+          <a:effectRef idx="2">
+            <a:schemeClr val="accent1"/>
+          </a:effectRef>
+          <a:fontRef idx="minor">
+            <a:schemeClr val="lt1"/>
+          </a:fontRef>
+        </p:style>
+        <p:txBody>
+          <a:bodyPr rtlCol="0" anchor="ctr"/>
+          <a:lstStyle/>
+          <a:p>
+            <a:pPr algn="ctr"/>
+          </a:p>
+        </p:txBody>
+      </p:sp>
+      <p:sp>
+        <p:nvSpPr>
+          <p:cNvPr id="79" name="TextBox 78"/>
+          <p:cNvSpPr txBox="1"/>
+          <p:nvPr/>
+        </p:nvSpPr>
+        <p:spPr>
+          <a:xfrm>
+            <a:off x="8705088" y="5065776"/>
+            <a:ext cx="2779776" cy="548640"/>
+          </a:xfrm>
+          <a:prstGeom prst="rect">
+            <a:avLst/>
+          </a:prstGeom>
+          <a:noFill/>
+        </p:spPr>
+        <p:txBody>
+          <a:bodyPr wrap="square" lIns="0" rIns="0" tIns="0" bIns="0">
+            <a:spAutoFit/>
+          </a:bodyPr>
+          <a:lstStyle/>
+          <a:p>
+            <a:r>
+              <a:rPr sz="1150" b="1">
+                <a:solidFill>
+                  <a:srgbClr val="061F79"/>
+                </a:solidFill>
+                <a:latin typeface="Arial"/>
+              </a:rPr>
+              <a:t>Location and talent roadmap</a:t>
+            </a:r>
+          </a:p>
+          <a:p>
+            <a:pPr>
+              <a:spcBef>
+                <a:spcPts val="300"/>
+              </a:spcBef>
+            </a:pPr>
+            <a:r>
+              <a:rPr sz="1000" b="0">
+                <a:solidFill>
+                  <a:srgbClr val="000000"/>
+                </a:solidFill>
+                <a:latin typeface="Arial"/>
+              </a:rPr>
+              <a:t>GLS 2.0 disposition and 90-day mobilization plan</a:t>
+            </a:r>
+          </a:p>
+        </p:txBody>
+      </p:sp>
     </p:spTree>
   </p:cSld>
   <p:clrMapOvr>

</xml_diff>

<commit_message>
Fix duplicate shape IDs that triggered PowerPoint repair prompt
Co-Authored-By: Claude Fable 5 <noreply@anthropic.com>
Claude-Session: https://claude.ai/code/session_01A3Z3HHfQP1XqLkWjeuhpsJ
</commit_message>
<xml_diff>
--- a/proposal/20260721_TU_Three_Pager_vDraft.pptx
+++ b/proposal/20260721_TU_Three_Pager_vDraft.pptx
@@ -20993,7 +20993,7 @@
                   <p:embed/>
                   <p:pic>
                     <p:nvPicPr>
-                      <p:cNvPr id="73" name="think-cell data - do not delete" hidden="1">
+                      <p:cNvPr id="74" name="think-cell data - do not delete" hidden="1">
                         <a:extLst>
                           <a:ext uri="{FF2B5EF4-FFF2-40B4-BE49-F238E27FC236}">
                             <a16:creationId xmlns:a16="http://schemas.microsoft.com/office/drawing/2014/main" id="{4C176148-2A0D-6E14-6CFF-F074BC1D8130}"/>
@@ -22070,7 +22070,7 @@
       </p:sp>
       <p:sp>
         <p:nvSpPr>
-          <p:cNvPr id="17" name="TextBox 16"/>
+          <p:cNvPr id="75" name="TextBox 16"/>
           <p:cNvSpPr txBox="1"/>
           <p:nvPr/>
         </p:nvSpPr>
@@ -22105,7 +22105,7 @@
       </p:sp>
       <p:cxnSp>
         <p:nvCxnSpPr>
-          <p:cNvPr id="54" name="LineBasicImpact 54">
+          <p:cNvPr id="76" name="LineBasicImpact 54">
             <a:extLst>
               <a:ext uri="{FF2B5EF4-FFF2-40B4-BE49-F238E27FC236}">
                 <a16:creationId xmlns:a16="http://schemas.microsoft.com/office/drawing/2014/main" id="{1BAEDC8C-7A5B-6C3B-4369-6F78188BB1E8}"/>
@@ -22154,7 +22154,7 @@
       </p:cxnSp>
       <p:sp>
         <p:nvSpPr>
-          <p:cNvPr id="19" name="TextBox 18"/>
+          <p:cNvPr id="77" name="TextBox 18"/>
           <p:cNvSpPr txBox="1">
             <a:spLocks/>
           </p:cNvSpPr>
@@ -22206,7 +22206,7 @@
       </p:sp>
       <p:sp>
         <p:nvSpPr>
-          <p:cNvPr id="19" name="TextBox 18"/>
+          <p:cNvPr id="78" name="TextBox 18"/>
           <p:cNvSpPr txBox="1">
             <a:spLocks/>
           </p:cNvSpPr>
@@ -22258,7 +22258,7 @@
       </p:sp>
       <p:sp>
         <p:nvSpPr>
-          <p:cNvPr id="19" name="TextBox 18"/>
+          <p:cNvPr id="79" name="TextBox 18"/>
           <p:cNvSpPr txBox="1">
             <a:spLocks/>
           </p:cNvSpPr>
@@ -22310,7 +22310,7 @@
       </p:sp>
       <p:sp>
         <p:nvSpPr>
-          <p:cNvPr id="17" name="TextBox 16"/>
+          <p:cNvPr id="80" name="TextBox 16"/>
           <p:cNvSpPr txBox="1"/>
           <p:nvPr/>
         </p:nvSpPr>
@@ -22345,7 +22345,7 @@
       </p:sp>
       <p:cxnSp>
         <p:nvCxnSpPr>
-          <p:cNvPr id="54" name="LineBasicImpact 54">
+          <p:cNvPr id="81" name="LineBasicImpact 54">
             <a:extLst>
               <a:ext uri="{FF2B5EF4-FFF2-40B4-BE49-F238E27FC236}">
                 <a16:creationId xmlns:a16="http://schemas.microsoft.com/office/drawing/2014/main" id="{1BAEDC8C-7A5B-6C3B-4369-6F78188BB1E8}"/>
@@ -22394,7 +22394,7 @@
       </p:cxnSp>
       <p:sp>
         <p:nvSpPr>
-          <p:cNvPr id="19" name="TextBox 18"/>
+          <p:cNvPr id="82" name="TextBox 18"/>
           <p:cNvSpPr txBox="1">
             <a:spLocks/>
           </p:cNvSpPr>
@@ -22446,7 +22446,7 @@
       </p:sp>
       <p:sp>
         <p:nvSpPr>
-          <p:cNvPr id="19" name="TextBox 18"/>
+          <p:cNvPr id="83" name="TextBox 18"/>
           <p:cNvSpPr txBox="1">
             <a:spLocks/>
           </p:cNvSpPr>
@@ -22498,7 +22498,7 @@
       </p:sp>
       <p:sp>
         <p:nvSpPr>
-          <p:cNvPr id="19" name="TextBox 18"/>
+          <p:cNvPr id="84" name="TextBox 18"/>
           <p:cNvSpPr txBox="1">
             <a:spLocks/>
           </p:cNvSpPr>
@@ -22550,7 +22550,7 @@
       </p:sp>
       <p:sp>
         <p:nvSpPr>
-          <p:cNvPr id="17" name="TextBox 16"/>
+          <p:cNvPr id="85" name="TextBox 16"/>
           <p:cNvSpPr txBox="1"/>
           <p:nvPr/>
         </p:nvSpPr>
@@ -22585,7 +22585,7 @@
       </p:sp>
       <p:cxnSp>
         <p:nvCxnSpPr>
-          <p:cNvPr id="54" name="LineBasicImpact 54">
+          <p:cNvPr id="86" name="LineBasicImpact 54">
             <a:extLst>
               <a:ext uri="{FF2B5EF4-FFF2-40B4-BE49-F238E27FC236}">
                 <a16:creationId xmlns:a16="http://schemas.microsoft.com/office/drawing/2014/main" id="{1BAEDC8C-7A5B-6C3B-4369-6F78188BB1E8}"/>
@@ -22634,7 +22634,7 @@
       </p:cxnSp>
       <p:sp>
         <p:nvSpPr>
-          <p:cNvPr id="19" name="TextBox 18"/>
+          <p:cNvPr id="87" name="TextBox 18"/>
           <p:cNvSpPr txBox="1">
             <a:spLocks/>
           </p:cNvSpPr>
@@ -22686,7 +22686,7 @@
       </p:sp>
       <p:sp>
         <p:nvSpPr>
-          <p:cNvPr id="19" name="TextBox 18"/>
+          <p:cNvPr id="88" name="TextBox 18"/>
           <p:cNvSpPr txBox="1">
             <a:spLocks/>
           </p:cNvSpPr>
@@ -22738,7 +22738,7 @@
       </p:sp>
       <p:sp>
         <p:nvSpPr>
-          <p:cNvPr id="17" name="TextBox 16"/>
+          <p:cNvPr id="89" name="TextBox 16"/>
           <p:cNvSpPr txBox="1"/>
           <p:nvPr/>
         </p:nvSpPr>
@@ -22773,7 +22773,7 @@
       </p:sp>
       <p:cxnSp>
         <p:nvCxnSpPr>
-          <p:cNvPr id="54" name="LineBasicImpact 54">
+          <p:cNvPr id="90" name="LineBasicImpact 54">
             <a:extLst>
               <a:ext uri="{FF2B5EF4-FFF2-40B4-BE49-F238E27FC236}">
                 <a16:creationId xmlns:a16="http://schemas.microsoft.com/office/drawing/2014/main" id="{1BAEDC8C-7A5B-6C3B-4369-6F78188BB1E8}"/>
@@ -22822,7 +22822,7 @@
       </p:cxnSp>
       <p:sp>
         <p:nvSpPr>
-          <p:cNvPr id="19" name="TextBox 18"/>
+          <p:cNvPr id="91" name="TextBox 18"/>
           <p:cNvSpPr txBox="1">
             <a:spLocks/>
           </p:cNvSpPr>
@@ -22874,7 +22874,7 @@
       </p:sp>
       <p:sp>
         <p:nvSpPr>
-          <p:cNvPr id="19" name="TextBox 18"/>
+          <p:cNvPr id="92" name="TextBox 18"/>
           <p:cNvSpPr txBox="1">
             <a:spLocks/>
           </p:cNvSpPr>

</xml_diff>

<commit_message>
Clean rebuild from pristine draft with full OOXML validation
Rebuilt with pure python-pptx API (no element cloning); validated with
Apache POI strict parse + ECMA-376 schema validation against the pristine
file as control, plus rels/content-type/ID parity checks.

Co-Authored-By: Claude Fable 5 <noreply@anthropic.com>
Claude-Session: https://claude.ai/code/session_01A3Z3HHfQP1XqLkWjeuhpsJ
</commit_message>
<xml_diff>
--- a/proposal/20260721_TU_Three_Pager_vDraft.pptx
+++ b/proposal/20260721_TU_Three_Pager_vDraft.pptx
@@ -19400,7 +19400,7 @@
         <p:spPr>
           <a:xfrm>
             <a:off x="557784" y="1133856"/>
-            <a:ext cx="5989320" cy="475488"/>
+            <a:ext cx="5989320" cy="402336"/>
           </a:xfrm>
           <a:prstGeom prst="rect">
             <a:avLst/>
@@ -19415,7 +19415,7 @@
           <a:p>
             <a:pPr>
               <a:lnSpc>
-                <a:spcPct val="108000"/>
+                <a:spcPct val="105000"/>
               </a:lnSpc>
             </a:pPr>
             <a:r>
@@ -20993,7 +20993,7 @@
                   <p:embed/>
                   <p:pic>
                     <p:nvPicPr>
-                      <p:cNvPr id="74" name="think-cell data - do not delete" hidden="1">
+                      <p:cNvPr id="73" name="think-cell data - do not delete" hidden="1">
                         <a:extLst>
                           <a:ext uri="{FF2B5EF4-FFF2-40B4-BE49-F238E27FC236}">
                             <a16:creationId xmlns:a16="http://schemas.microsoft.com/office/drawing/2014/main" id="{4C176148-2A0D-6E14-6CFF-F074BC1D8130}"/>
@@ -21934,14 +21934,14 @@
       </p:pic>
       <p:sp>
         <p:nvSpPr>
-          <p:cNvPr id="17" name="TextBox 16"/>
+          <p:cNvPr id="74" name="TextBox 73"/>
           <p:cNvSpPr txBox="1"/>
           <p:nvPr/>
         </p:nvSpPr>
         <p:spPr>
           <a:xfrm>
-            <a:off x="5184980" y="1801368"/>
-            <a:ext cx="1143000" cy="548640"/>
+            <a:off x="5138928" y="1801368"/>
+            <a:ext cx="1078992" cy="548640"/>
           </a:xfrm>
           <a:prstGeom prst="rect">
             <a:avLst/>
@@ -21949,14 +21949,18 @@
           <a:noFill/>
         </p:spPr>
         <p:txBody>
-          <a:bodyPr wrap="square" lIns="0" tIns="0" rIns="0" bIns="0" anchor="t">
+          <a:bodyPr wrap="square" lIns="0" rIns="0" tIns="0" bIns="0">
             <a:spAutoFit/>
           </a:bodyPr>
           <a:lstStyle/>
           <a:p>
-            <a:pPr algn="l"/>
+            <a:pPr>
+              <a:lnSpc>
+                <a:spcPct val="100000"/>
+              </a:lnSpc>
+            </a:pPr>
             <a:r>
-              <a:rPr sz="1200" b="1" i="0" dirty="0">
+              <a:rPr sz="1100" b="1">
                 <a:solidFill>
                   <a:srgbClr val="2251FF"/>
                 </a:solidFill>
@@ -21969,46 +21973,33 @@
       </p:sp>
       <p:cxnSp>
         <p:nvCxnSpPr>
-          <p:cNvPr id="54" name="LineBasicImpact 54">
-            <a:extLst>
-              <a:ext uri="{FF2B5EF4-FFF2-40B4-BE49-F238E27FC236}">
-                <a16:creationId xmlns:a16="http://schemas.microsoft.com/office/drawing/2014/main" id="{1BAEDC8C-7A5B-6C3B-4369-6F78188BB1E8}"/>
-              </a:ext>
-            </a:extLst>
-          </p:cNvPr>
-          <p:cNvCxnSpPr>
-            <a:cxnSpLocks/>
-          </p:cNvCxnSpPr>
-          <p:nvPr>
-            <p:custDataLst>
-              <p:tags r:id="rId5"/>
-            </p:custDataLst>
-          </p:nvPr>
+          <p:cNvPr id="75" name="Connector 74"/>
+          <p:cNvCxnSpPr/>
+          <p:nvPr/>
         </p:nvCxnSpPr>
         <p:spPr>
           <a:xfrm>
-            <a:off x="6282545" y="1801368"/>
+            <a:off x="6281928" y="1801368"/>
             <a:ext cx="0" cy="365760"/>
           </a:xfrm>
-          <a:prstGeom prst="straightConnector1">
+          <a:prstGeom prst="line">
             <a:avLst/>
           </a:prstGeom>
-          <a:ln w="19050" cap="flat">
+          <a:ln w="19050">
             <a:solidFill>
-              <a:schemeClr val="accent3"/>
+              <a:srgbClr val="2251FF"/>
             </a:solidFill>
-            <a:miter lim="800000"/>
-            <a:tailEnd type="none"/>
           </a:ln>
+          <a:effectLst/>
         </p:spPr>
         <p:style>
-          <a:lnRef idx="1">
+          <a:lnRef idx="2">
             <a:schemeClr val="accent1"/>
           </a:lnRef>
           <a:fillRef idx="0">
             <a:schemeClr val="accent1"/>
           </a:fillRef>
-          <a:effectRef idx="0">
+          <a:effectRef idx="1">
             <a:schemeClr val="accent1"/>
           </a:effectRef>
           <a:fontRef idx="minor">
@@ -22018,16 +22009,14 @@
       </p:cxnSp>
       <p:sp>
         <p:nvSpPr>
-          <p:cNvPr id="19" name="TextBox 18"/>
-          <p:cNvSpPr txBox="1">
-            <a:spLocks/>
-          </p:cNvSpPr>
+          <p:cNvPr id="76" name="TextBox 75"/>
+          <p:cNvSpPr txBox="1"/>
           <p:nvPr/>
         </p:nvSpPr>
         <p:spPr>
           <a:xfrm>
-            <a:off x="6430956" y="1801368"/>
-            <a:ext cx="5203257" cy="365760"/>
+            <a:off x="6428232" y="1801368"/>
+            <a:ext cx="5202936" cy="365760"/>
           </a:xfrm>
           <a:prstGeom prst="rect">
             <a:avLst/>
@@ -22035,20 +22024,27 @@
           <a:noFill/>
         </p:spPr>
         <p:txBody>
-          <a:bodyPr wrap="square" lIns="0" tIns="0" rIns="0" bIns="0" anchor="t">
+          <a:bodyPr wrap="square" lIns="0" rIns="0" tIns="0" bIns="0">
             <a:spAutoFit/>
           </a:bodyPr>
           <a:lstStyle/>
           <a:p>
-            <a:pPr marL="171450" indent="-171450" algn="l">
+            <a:pPr marL="137160" indent="-137160">
               <a:lnSpc>
                 <a:spcPct val="100000"/>
               </a:lnSpc>
-              <a:buFont typeface="Arial" panose="020B0604020202020204" pitchFamily="34" charset="0"/>
-              <a:buChar char="•"/>
             </a:pPr>
             <a:r>
-              <a:rPr sz="1100" b="1" i="0" dirty="0">
+              <a:rPr sz="1100" b="0">
+                <a:solidFill>
+                  <a:srgbClr val="000000"/>
+                </a:solidFill>
+                <a:latin typeface="Arial"/>
+              </a:rPr>
+              <a:t>•  </a:t>
+            </a:r>
+            <a:r>
+              <a:rPr sz="1100" b="1">
                 <a:solidFill>
                   <a:srgbClr val="000000"/>
                 </a:solidFill>
@@ -22057,7 +22053,7 @@
               <a:t>What would a right-sized TU look like</a:t>
             </a:r>
             <a:r>
-              <a:rPr sz="1100" b="0" i="0" dirty="0">
+              <a:rPr sz="1100" b="0">
                 <a:solidFill>
                   <a:srgbClr val="000000"/>
                 </a:solidFill>
@@ -22070,14 +22066,14 @@
       </p:sp>
       <p:sp>
         <p:nvSpPr>
-          <p:cNvPr id="75" name="TextBox 16"/>
+          <p:cNvPr id="77" name="TextBox 76"/>
           <p:cNvSpPr txBox="1"/>
           <p:nvPr/>
         </p:nvSpPr>
         <p:spPr>
           <a:xfrm>
-            <a:off x="5184980" y="2276856"/>
-            <a:ext cx="1143000" cy="777240"/>
+            <a:off x="5138928" y="2276856"/>
+            <a:ext cx="1078992" cy="777240"/>
           </a:xfrm>
           <a:prstGeom prst="rect">
             <a:avLst/>
@@ -22085,14 +22081,18 @@
           <a:noFill/>
         </p:spPr>
         <p:txBody>
-          <a:bodyPr wrap="square" lIns="0" tIns="0" rIns="0" bIns="0" anchor="t">
+          <a:bodyPr wrap="square" lIns="0" rIns="0" tIns="0" bIns="0">
             <a:spAutoFit/>
           </a:bodyPr>
           <a:lstStyle/>
           <a:p>
-            <a:pPr algn="l"/>
+            <a:pPr>
+              <a:lnSpc>
+                <a:spcPct val="100000"/>
+              </a:lnSpc>
+            </a:pPr>
             <a:r>
-              <a:rPr sz="1200" b="1" i="0" dirty="0">
+              <a:rPr sz="1100" b="1">
                 <a:solidFill>
                   <a:srgbClr val="2251FF"/>
                 </a:solidFill>
@@ -22105,46 +22105,33 @@
       </p:sp>
       <p:cxnSp>
         <p:nvCxnSpPr>
-          <p:cNvPr id="76" name="LineBasicImpact 54">
-            <a:extLst>
-              <a:ext uri="{FF2B5EF4-FFF2-40B4-BE49-F238E27FC236}">
-                <a16:creationId xmlns:a16="http://schemas.microsoft.com/office/drawing/2014/main" id="{1BAEDC8C-7A5B-6C3B-4369-6F78188BB1E8}"/>
-              </a:ext>
-            </a:extLst>
-          </p:cNvPr>
-          <p:cNvCxnSpPr>
-            <a:cxnSpLocks/>
-          </p:cNvCxnSpPr>
-          <p:nvPr>
-            <p:custDataLst>
-              <p:tags r:id="rId5"/>
-            </p:custDataLst>
-          </p:nvPr>
+          <p:cNvPr id="78" name="Connector 77"/>
+          <p:cNvCxnSpPr/>
+          <p:nvPr/>
         </p:nvCxnSpPr>
         <p:spPr>
           <a:xfrm>
-            <a:off x="6282545" y="2276856"/>
+            <a:off x="6281928" y="2276856"/>
             <a:ext cx="0" cy="1572768"/>
           </a:xfrm>
-          <a:prstGeom prst="straightConnector1">
+          <a:prstGeom prst="line">
             <a:avLst/>
           </a:prstGeom>
-          <a:ln w="19050" cap="flat">
+          <a:ln w="19050">
             <a:solidFill>
-              <a:schemeClr val="accent3"/>
+              <a:srgbClr val="2251FF"/>
             </a:solidFill>
-            <a:miter lim="800000"/>
-            <a:tailEnd type="none"/>
           </a:ln>
+          <a:effectLst/>
         </p:spPr>
         <p:style>
-          <a:lnRef idx="1">
+          <a:lnRef idx="2">
             <a:schemeClr val="accent1"/>
           </a:lnRef>
           <a:fillRef idx="0">
             <a:schemeClr val="accent1"/>
           </a:fillRef>
-          <a:effectRef idx="0">
+          <a:effectRef idx="1">
             <a:schemeClr val="accent1"/>
           </a:effectRef>
           <a:fontRef idx="minor">
@@ -22154,16 +22141,14 @@
       </p:cxnSp>
       <p:sp>
         <p:nvSpPr>
-          <p:cNvPr id="77" name="TextBox 18"/>
-          <p:cNvSpPr txBox="1">
-            <a:spLocks/>
-          </p:cNvSpPr>
+          <p:cNvPr id="79" name="TextBox 78"/>
+          <p:cNvSpPr txBox="1"/>
           <p:nvPr/>
         </p:nvSpPr>
         <p:spPr>
           <a:xfrm>
-            <a:off x="6430956" y="2276856"/>
-            <a:ext cx="5203257" cy="548640"/>
+            <a:off x="6428232" y="2276856"/>
+            <a:ext cx="5202936" cy="548640"/>
           </a:xfrm>
           <a:prstGeom prst="rect">
             <a:avLst/>
@@ -22171,20 +22156,27 @@
           <a:noFill/>
         </p:spPr>
         <p:txBody>
-          <a:bodyPr wrap="square" lIns="0" tIns="0" rIns="0" bIns="0" anchor="t">
+          <a:bodyPr wrap="square" lIns="0" rIns="0" tIns="0" bIns="0">
             <a:spAutoFit/>
           </a:bodyPr>
           <a:lstStyle/>
           <a:p>
-            <a:pPr marL="171450" indent="-171450" algn="l">
+            <a:pPr marL="137160" indent="-137160">
               <a:lnSpc>
                 <a:spcPct val="100000"/>
               </a:lnSpc>
-              <a:buFont typeface="Arial" panose="020B0604020202020204" pitchFamily="34" charset="0"/>
-              <a:buChar char="•"/>
             </a:pPr>
             <a:r>
-              <a:rPr sz="1100" b="1" i="0" dirty="0">
+              <a:rPr sz="1100" b="0">
+                <a:solidFill>
+                  <a:srgbClr val="000000"/>
+                </a:solidFill>
+                <a:latin typeface="Arial"/>
+              </a:rPr>
+              <a:t>•  </a:t>
+            </a:r>
+            <a:r>
+              <a:rPr sz="1100" b="1">
                 <a:solidFill>
                   <a:srgbClr val="000000"/>
                 </a:solidFill>
@@ -22193,7 +22185,7 @@
               <a:t>Which archetypes do true platform orgs follow</a:t>
             </a:r>
             <a:r>
-              <a:rPr sz="1100" b="0" i="0" dirty="0">
+              <a:rPr sz="1100" b="0">
                 <a:solidFill>
                   <a:srgbClr val="000000"/>
                 </a:solidFill>
@@ -22206,16 +22198,14 @@
       </p:sp>
       <p:sp>
         <p:nvSpPr>
-          <p:cNvPr id="78" name="TextBox 18"/>
-          <p:cNvSpPr txBox="1">
-            <a:spLocks/>
-          </p:cNvSpPr>
+          <p:cNvPr id="80" name="TextBox 79"/>
+          <p:cNvSpPr txBox="1"/>
           <p:nvPr/>
         </p:nvSpPr>
         <p:spPr>
           <a:xfrm>
-            <a:off x="6430956" y="2880360"/>
-            <a:ext cx="5203257" cy="548640"/>
+            <a:off x="6428232" y="2880360"/>
+            <a:ext cx="5202936" cy="548640"/>
           </a:xfrm>
           <a:prstGeom prst="rect">
             <a:avLst/>
@@ -22223,20 +22213,27 @@
           <a:noFill/>
         </p:spPr>
         <p:txBody>
-          <a:bodyPr wrap="square" lIns="0" tIns="0" rIns="0" bIns="0" anchor="t">
+          <a:bodyPr wrap="square" lIns="0" rIns="0" tIns="0" bIns="0">
             <a:spAutoFit/>
           </a:bodyPr>
           <a:lstStyle/>
           <a:p>
-            <a:pPr marL="171450" indent="-171450" algn="l">
+            <a:pPr marL="137160" indent="-137160">
               <a:lnSpc>
                 <a:spcPct val="100000"/>
               </a:lnSpc>
-              <a:buFont typeface="Arial" panose="020B0604020202020204" pitchFamily="34" charset="0"/>
-              <a:buChar char="•"/>
             </a:pPr>
             <a:r>
-              <a:rPr sz="1100" b="1" i="0" dirty="0">
+              <a:rPr sz="1100" b="0">
+                <a:solidFill>
+                  <a:srgbClr val="000000"/>
+                </a:solidFill>
+                <a:latin typeface="Arial"/>
+              </a:rPr>
+              <a:t>•  </a:t>
+            </a:r>
+            <a:r>
+              <a:rPr sz="1100" b="1">
                 <a:solidFill>
                   <a:srgbClr val="000000"/>
                 </a:solidFill>
@@ -22245,7 +22242,7 @@
               <a:t>What size and composition for the platform and product engineering teams</a:t>
             </a:r>
             <a:r>
-              <a:rPr sz="1100" b="0" i="0" dirty="0">
+              <a:rPr sz="1100" b="0">
                 <a:solidFill>
                   <a:srgbClr val="000000"/>
                 </a:solidFill>
@@ -22258,16 +22255,14 @@
       </p:sp>
       <p:sp>
         <p:nvSpPr>
-          <p:cNvPr id="79" name="TextBox 18"/>
-          <p:cNvSpPr txBox="1">
-            <a:spLocks/>
-          </p:cNvSpPr>
+          <p:cNvPr id="81" name="TextBox 80"/>
+          <p:cNvSpPr txBox="1"/>
           <p:nvPr/>
         </p:nvSpPr>
         <p:spPr>
           <a:xfrm>
-            <a:off x="6430956" y="3483864"/>
-            <a:ext cx="5203257" cy="365760"/>
+            <a:off x="6428232" y="3483864"/>
+            <a:ext cx="5202936" cy="365760"/>
           </a:xfrm>
           <a:prstGeom prst="rect">
             <a:avLst/>
@@ -22275,20 +22270,27 @@
           <a:noFill/>
         </p:spPr>
         <p:txBody>
-          <a:bodyPr wrap="square" lIns="0" tIns="0" rIns="0" bIns="0" anchor="t">
+          <a:bodyPr wrap="square" lIns="0" rIns="0" tIns="0" bIns="0">
             <a:spAutoFit/>
           </a:bodyPr>
           <a:lstStyle/>
           <a:p>
-            <a:pPr marL="171450" indent="-171450" algn="l">
+            <a:pPr marL="137160" indent="-137160">
               <a:lnSpc>
                 <a:spcPct val="100000"/>
               </a:lnSpc>
-              <a:buFont typeface="Arial" panose="020B0604020202020204" pitchFamily="34" charset="0"/>
-              <a:buChar char="•"/>
             </a:pPr>
             <a:r>
-              <a:rPr sz="1100" b="1" i="0" dirty="0">
+              <a:rPr sz="1100" b="0">
+                <a:solidFill>
+                  <a:srgbClr val="000000"/>
+                </a:solidFill>
+                <a:latin typeface="Arial"/>
+              </a:rPr>
+              <a:t>•  </a:t>
+            </a:r>
+            <a:r>
+              <a:rPr sz="1100" b="1">
                 <a:solidFill>
                   <a:srgbClr val="000000"/>
                 </a:solidFill>
@@ -22297,7 +22299,7 @@
               <a:t>What are the core design choices</a:t>
             </a:r>
             <a:r>
-              <a:rPr sz="1100" b="0" i="0" dirty="0">
+              <a:rPr sz="1100" b="0">
                 <a:solidFill>
                   <a:srgbClr val="000000"/>
                 </a:solidFill>
@@ -22310,14 +22312,14 @@
       </p:sp>
       <p:sp>
         <p:nvSpPr>
-          <p:cNvPr id="80" name="TextBox 16"/>
+          <p:cNvPr id="82" name="TextBox 81"/>
           <p:cNvSpPr txBox="1"/>
           <p:nvPr/>
         </p:nvSpPr>
         <p:spPr>
           <a:xfrm>
-            <a:off x="5184980" y="3977639"/>
-            <a:ext cx="1143000" cy="777240"/>
+            <a:off x="5138928" y="3977639"/>
+            <a:ext cx="1078992" cy="777240"/>
           </a:xfrm>
           <a:prstGeom prst="rect">
             <a:avLst/>
@@ -22325,14 +22327,18 @@
           <a:noFill/>
         </p:spPr>
         <p:txBody>
-          <a:bodyPr wrap="square" lIns="0" tIns="0" rIns="0" bIns="0" anchor="t">
+          <a:bodyPr wrap="square" lIns="0" rIns="0" tIns="0" bIns="0">
             <a:spAutoFit/>
           </a:bodyPr>
           <a:lstStyle/>
           <a:p>
-            <a:pPr algn="l"/>
+            <a:pPr>
+              <a:lnSpc>
+                <a:spcPct val="100000"/>
+              </a:lnSpc>
+            </a:pPr>
             <a:r>
-              <a:rPr sz="1200" b="1" i="0" dirty="0">
+              <a:rPr sz="1100" b="1">
                 <a:solidFill>
                   <a:srgbClr val="2251FF"/>
                 </a:solidFill>
@@ -22345,46 +22351,33 @@
       </p:sp>
       <p:cxnSp>
         <p:nvCxnSpPr>
-          <p:cNvPr id="81" name="LineBasicImpact 54">
-            <a:extLst>
-              <a:ext uri="{FF2B5EF4-FFF2-40B4-BE49-F238E27FC236}">
-                <a16:creationId xmlns:a16="http://schemas.microsoft.com/office/drawing/2014/main" id="{1BAEDC8C-7A5B-6C3B-4369-6F78188BB1E8}"/>
-              </a:ext>
-            </a:extLst>
-          </p:cNvPr>
-          <p:cNvCxnSpPr>
-            <a:cxnSpLocks/>
-          </p:cNvCxnSpPr>
-          <p:nvPr>
-            <p:custDataLst>
-              <p:tags r:id="rId5"/>
-            </p:custDataLst>
-          </p:nvPr>
+          <p:cNvPr id="83" name="Connector 82"/>
+          <p:cNvCxnSpPr/>
+          <p:nvPr/>
         </p:nvCxnSpPr>
         <p:spPr>
           <a:xfrm>
-            <a:off x="6282545" y="3977639"/>
-            <a:ext cx="0" cy="996696"/>
+            <a:off x="6281928" y="3977639"/>
+            <a:ext cx="0" cy="1033273"/>
           </a:xfrm>
-          <a:prstGeom prst="straightConnector1">
+          <a:prstGeom prst="line">
             <a:avLst/>
           </a:prstGeom>
-          <a:ln w="19050" cap="flat">
+          <a:ln w="19050">
             <a:solidFill>
-              <a:schemeClr val="accent3"/>
+              <a:srgbClr val="2251FF"/>
             </a:solidFill>
-            <a:miter lim="800000"/>
-            <a:tailEnd type="none"/>
           </a:ln>
+          <a:effectLst/>
         </p:spPr>
         <p:style>
-          <a:lnRef idx="1">
+          <a:lnRef idx="2">
             <a:schemeClr val="accent1"/>
           </a:lnRef>
           <a:fillRef idx="0">
             <a:schemeClr val="accent1"/>
           </a:fillRef>
-          <a:effectRef idx="0">
+          <a:effectRef idx="1">
             <a:schemeClr val="accent1"/>
           </a:effectRef>
           <a:fontRef idx="minor">
@@ -22394,16 +22387,14 @@
       </p:cxnSp>
       <p:sp>
         <p:nvSpPr>
-          <p:cNvPr id="82" name="TextBox 18"/>
-          <p:cNvSpPr txBox="1">
-            <a:spLocks/>
-          </p:cNvSpPr>
+          <p:cNvPr id="84" name="TextBox 83"/>
+          <p:cNvSpPr txBox="1"/>
           <p:nvPr/>
         </p:nvSpPr>
         <p:spPr>
           <a:xfrm>
-            <a:off x="6430956" y="3977639"/>
-            <a:ext cx="5203257" cy="365760"/>
+            <a:off x="6428232" y="3977639"/>
+            <a:ext cx="5202936" cy="365760"/>
           </a:xfrm>
           <a:prstGeom prst="rect">
             <a:avLst/>
@@ -22411,20 +22402,27 @@
           <a:noFill/>
         </p:spPr>
         <p:txBody>
-          <a:bodyPr wrap="square" lIns="0" tIns="0" rIns="0" bIns="0" anchor="t">
+          <a:bodyPr wrap="square" lIns="0" rIns="0" tIns="0" bIns="0">
             <a:spAutoFit/>
           </a:bodyPr>
           <a:lstStyle/>
           <a:p>
-            <a:pPr marL="171450" indent="-171450" algn="l">
+            <a:pPr marL="137160" indent="-137160">
               <a:lnSpc>
                 <a:spcPct val="100000"/>
               </a:lnSpc>
-              <a:buFont typeface="Arial" panose="020B0604020202020204" pitchFamily="34" charset="0"/>
-              <a:buChar char="•"/>
             </a:pPr>
             <a:r>
-              <a:rPr sz="1100" b="1" i="0" dirty="0">
+              <a:rPr sz="1100" b="0">
+                <a:solidFill>
+                  <a:srgbClr val="000000"/>
+                </a:solidFill>
+                <a:latin typeface="Arial"/>
+              </a:rPr>
+              <a:t>•  </a:t>
+            </a:r>
+            <a:r>
+              <a:rPr sz="1100" b="1">
                 <a:solidFill>
                   <a:srgbClr val="000000"/>
                 </a:solidFill>
@@ -22433,7 +22431,7 @@
               <a:t>How will AI change talent demand</a:t>
             </a:r>
             <a:r>
-              <a:rPr sz="1100" b="0" i="0" dirty="0">
+              <a:rPr sz="1100" b="0">
                 <a:solidFill>
                   <a:srgbClr val="000000"/>
                 </a:solidFill>
@@ -22446,16 +22444,14 @@
       </p:sp>
       <p:sp>
         <p:nvSpPr>
-          <p:cNvPr id="83" name="TextBox 18"/>
-          <p:cNvSpPr txBox="1">
-            <a:spLocks/>
-          </p:cNvSpPr>
+          <p:cNvPr id="85" name="TextBox 84"/>
+          <p:cNvSpPr txBox="1"/>
           <p:nvPr/>
         </p:nvSpPr>
         <p:spPr>
           <a:xfrm>
-            <a:off x="6430956" y="4398264"/>
-            <a:ext cx="5203257" cy="365760"/>
+            <a:off x="6428232" y="4398264"/>
+            <a:ext cx="5202936" cy="365760"/>
           </a:xfrm>
           <a:prstGeom prst="rect">
             <a:avLst/>
@@ -22463,20 +22459,27 @@
           <a:noFill/>
         </p:spPr>
         <p:txBody>
-          <a:bodyPr wrap="square" lIns="0" tIns="0" rIns="0" bIns="0" anchor="t">
+          <a:bodyPr wrap="square" lIns="0" rIns="0" tIns="0" bIns="0">
             <a:spAutoFit/>
           </a:bodyPr>
           <a:lstStyle/>
           <a:p>
-            <a:pPr marL="171450" indent="-171450" algn="l">
+            <a:pPr marL="137160" indent="-137160">
               <a:lnSpc>
                 <a:spcPct val="100000"/>
               </a:lnSpc>
-              <a:buFont typeface="Arial" panose="020B0604020202020204" pitchFamily="34" charset="0"/>
-              <a:buChar char="•"/>
             </a:pPr>
             <a:r>
-              <a:rPr sz="1100" b="1" i="0" dirty="0">
+              <a:rPr sz="1100" b="0">
+                <a:solidFill>
+                  <a:srgbClr val="000000"/>
+                </a:solidFill>
+                <a:latin typeface="Arial"/>
+              </a:rPr>
+              <a:t>•  </a:t>
+            </a:r>
+            <a:r>
+              <a:rPr sz="1100" b="1">
                 <a:solidFill>
                   <a:srgbClr val="000000"/>
                 </a:solidFill>
@@ -22485,7 +22488,7 @@
               <a:t>What size, shape, and skills</a:t>
             </a:r>
             <a:r>
-              <a:rPr sz="1100" b="0" i="0" dirty="0">
+              <a:rPr sz="1100" b="0">
                 <a:solidFill>
                   <a:srgbClr val="000000"/>
                 </a:solidFill>
@@ -22498,16 +22501,14 @@
       </p:sp>
       <p:sp>
         <p:nvSpPr>
-          <p:cNvPr id="84" name="TextBox 18"/>
-          <p:cNvSpPr txBox="1">
-            <a:spLocks/>
-          </p:cNvSpPr>
+          <p:cNvPr id="86" name="TextBox 85"/>
+          <p:cNvSpPr txBox="1"/>
           <p:nvPr/>
         </p:nvSpPr>
         <p:spPr>
           <a:xfrm>
-            <a:off x="6430956" y="4818888"/>
-            <a:ext cx="5203257" cy="192024"/>
+            <a:off x="6428232" y="4818888"/>
+            <a:ext cx="5202936" cy="192024"/>
           </a:xfrm>
           <a:prstGeom prst="rect">
             <a:avLst/>
@@ -22515,20 +22516,27 @@
           <a:noFill/>
         </p:spPr>
         <p:txBody>
-          <a:bodyPr wrap="square" lIns="0" tIns="0" rIns="0" bIns="0" anchor="t">
+          <a:bodyPr wrap="square" lIns="0" rIns="0" tIns="0" bIns="0">
             <a:spAutoFit/>
           </a:bodyPr>
           <a:lstStyle/>
           <a:p>
-            <a:pPr marL="171450" indent="-171450" algn="l">
+            <a:pPr marL="137160" indent="-137160">
               <a:lnSpc>
                 <a:spcPct val="100000"/>
               </a:lnSpc>
-              <a:buFont typeface="Arial" panose="020B0604020202020204" pitchFamily="34" charset="0"/>
-              <a:buChar char="•"/>
             </a:pPr>
             <a:r>
-              <a:rPr sz="1100" b="1" i="0" dirty="0">
+              <a:rPr sz="1100" b="0">
+                <a:solidFill>
+                  <a:srgbClr val="000000"/>
+                </a:solidFill>
+                <a:latin typeface="Arial"/>
+              </a:rPr>
+              <a:t>•  </a:t>
+            </a:r>
+            <a:r>
+              <a:rPr sz="1100" b="1">
                 <a:solidFill>
                   <a:srgbClr val="000000"/>
                 </a:solidFill>
@@ -22537,7 +22545,7 @@
               <a:t>What is the value case</a:t>
             </a:r>
             <a:r>
-              <a:rPr sz="1100" b="0" i="0" dirty="0">
+              <a:rPr sz="1100" b="0">
                 <a:solidFill>
                   <a:srgbClr val="000000"/>
                 </a:solidFill>
@@ -22550,14 +22558,14 @@
       </p:sp>
       <p:sp>
         <p:nvSpPr>
-          <p:cNvPr id="85" name="TextBox 16"/>
+          <p:cNvPr id="87" name="TextBox 86"/>
           <p:cNvSpPr txBox="1"/>
           <p:nvPr/>
         </p:nvSpPr>
         <p:spPr>
           <a:xfrm>
-            <a:off x="5184980" y="5138928"/>
-            <a:ext cx="1143000" cy="777240"/>
+            <a:off x="5138928" y="5138928"/>
+            <a:ext cx="1078992" cy="777240"/>
           </a:xfrm>
           <a:prstGeom prst="rect">
             <a:avLst/>
@@ -22565,14 +22573,18 @@
           <a:noFill/>
         </p:spPr>
         <p:txBody>
-          <a:bodyPr wrap="square" lIns="0" tIns="0" rIns="0" bIns="0" anchor="t">
+          <a:bodyPr wrap="square" lIns="0" rIns="0" tIns="0" bIns="0">
             <a:spAutoFit/>
           </a:bodyPr>
           <a:lstStyle/>
           <a:p>
-            <a:pPr algn="l"/>
+            <a:pPr>
+              <a:lnSpc>
+                <a:spcPct val="100000"/>
+              </a:lnSpc>
+            </a:pPr>
             <a:r>
-              <a:rPr sz="1200" b="1" i="0" dirty="0">
+              <a:rPr sz="1100" b="1">
                 <a:solidFill>
                   <a:srgbClr val="2251FF"/>
                 </a:solidFill>
@@ -22585,46 +22597,33 @@
       </p:sp>
       <p:cxnSp>
         <p:nvCxnSpPr>
-          <p:cNvPr id="86" name="LineBasicImpact 54">
-            <a:extLst>
-              <a:ext uri="{FF2B5EF4-FFF2-40B4-BE49-F238E27FC236}">
-                <a16:creationId xmlns:a16="http://schemas.microsoft.com/office/drawing/2014/main" id="{1BAEDC8C-7A5B-6C3B-4369-6F78188BB1E8}"/>
-              </a:ext>
-            </a:extLst>
-          </p:cNvPr>
-          <p:cNvCxnSpPr>
-            <a:cxnSpLocks/>
-          </p:cNvCxnSpPr>
-          <p:nvPr>
-            <p:custDataLst>
-              <p:tags r:id="rId5"/>
-            </p:custDataLst>
-          </p:nvPr>
+          <p:cNvPr id="88" name="Connector 87"/>
+          <p:cNvCxnSpPr/>
+          <p:nvPr/>
         </p:nvCxnSpPr>
         <p:spPr>
           <a:xfrm>
-            <a:off x="6282545" y="5138928"/>
-            <a:ext cx="0" cy="557784"/>
+            <a:off x="6281928" y="5138928"/>
+            <a:ext cx="0" cy="612648"/>
           </a:xfrm>
-          <a:prstGeom prst="straightConnector1">
+          <a:prstGeom prst="line">
             <a:avLst/>
           </a:prstGeom>
-          <a:ln w="19050" cap="flat">
+          <a:ln w="19050">
             <a:solidFill>
-              <a:schemeClr val="accent3"/>
+              <a:srgbClr val="2251FF"/>
             </a:solidFill>
-            <a:miter lim="800000"/>
-            <a:tailEnd type="none"/>
           </a:ln>
+          <a:effectLst/>
         </p:spPr>
         <p:style>
-          <a:lnRef idx="1">
+          <a:lnRef idx="2">
             <a:schemeClr val="accent1"/>
           </a:lnRef>
           <a:fillRef idx="0">
             <a:schemeClr val="accent1"/>
           </a:fillRef>
-          <a:effectRef idx="0">
+          <a:effectRef idx="1">
             <a:schemeClr val="accent1"/>
           </a:effectRef>
           <a:fontRef idx="minor">
@@ -22634,16 +22633,14 @@
       </p:cxnSp>
       <p:sp>
         <p:nvSpPr>
-          <p:cNvPr id="87" name="TextBox 18"/>
-          <p:cNvSpPr txBox="1">
-            <a:spLocks/>
-          </p:cNvSpPr>
+          <p:cNvPr id="89" name="TextBox 88"/>
+          <p:cNvSpPr txBox="1"/>
           <p:nvPr/>
         </p:nvSpPr>
         <p:spPr>
           <a:xfrm>
-            <a:off x="6430956" y="5138928"/>
-            <a:ext cx="5203257" cy="192024"/>
+            <a:off x="6428232" y="5138928"/>
+            <a:ext cx="5202936" cy="192024"/>
           </a:xfrm>
           <a:prstGeom prst="rect">
             <a:avLst/>
@@ -22651,20 +22648,27 @@
           <a:noFill/>
         </p:spPr>
         <p:txBody>
-          <a:bodyPr wrap="square" lIns="0" tIns="0" rIns="0" bIns="0" anchor="t">
+          <a:bodyPr wrap="square" lIns="0" rIns="0" tIns="0" bIns="0">
             <a:spAutoFit/>
           </a:bodyPr>
           <a:lstStyle/>
           <a:p>
-            <a:pPr marL="171450" indent="-171450" algn="l">
+            <a:pPr marL="137160" indent="-137160">
               <a:lnSpc>
                 <a:spcPct val="100000"/>
               </a:lnSpc>
-              <a:buFont typeface="Arial" panose="020B0604020202020204" pitchFamily="34" charset="0"/>
-              <a:buChar char="•"/>
             </a:pPr>
             <a:r>
-              <a:rPr sz="1100" b="1" i="0" dirty="0">
+              <a:rPr sz="1100" b="0">
+                <a:solidFill>
+                  <a:srgbClr val="000000"/>
+                </a:solidFill>
+                <a:latin typeface="Arial"/>
+              </a:rPr>
+              <a:t>•  </a:t>
+            </a:r>
+            <a:r>
+              <a:rPr sz="1100" b="1">
                 <a:solidFill>
                   <a:srgbClr val="000000"/>
                 </a:solidFill>
@@ -22673,7 +22677,7 @@
               <a:t>Which roles sit where</a:t>
             </a:r>
             <a:r>
-              <a:rPr sz="1100" b="0" i="0" dirty="0">
+              <a:rPr sz="1100" b="0">
                 <a:solidFill>
                   <a:srgbClr val="000000"/>
                 </a:solidFill>
@@ -22686,16 +22690,14 @@
       </p:sp>
       <p:sp>
         <p:nvSpPr>
-          <p:cNvPr id="88" name="TextBox 18"/>
-          <p:cNvSpPr txBox="1">
-            <a:spLocks/>
-          </p:cNvSpPr>
+          <p:cNvPr id="90" name="TextBox 89"/>
+          <p:cNvSpPr txBox="1"/>
           <p:nvPr/>
         </p:nvSpPr>
         <p:spPr>
           <a:xfrm>
-            <a:off x="6430956" y="5385816"/>
-            <a:ext cx="5203257" cy="365760"/>
+            <a:off x="6428232" y="5385816"/>
+            <a:ext cx="5202936" cy="365760"/>
           </a:xfrm>
           <a:prstGeom prst="rect">
             <a:avLst/>
@@ -22703,20 +22705,27 @@
           <a:noFill/>
         </p:spPr>
         <p:txBody>
-          <a:bodyPr wrap="square" lIns="0" tIns="0" rIns="0" bIns="0" anchor="t">
+          <a:bodyPr wrap="square" lIns="0" rIns="0" tIns="0" bIns="0">
             <a:spAutoFit/>
           </a:bodyPr>
           <a:lstStyle/>
           <a:p>
-            <a:pPr marL="171450" indent="-171450" algn="l">
+            <a:pPr marL="137160" indent="-137160">
               <a:lnSpc>
                 <a:spcPct val="100000"/>
               </a:lnSpc>
-              <a:buFont typeface="Arial" panose="020B0604020202020204" pitchFamily="34" charset="0"/>
-              <a:buChar char="•"/>
             </a:pPr>
             <a:r>
-              <a:rPr sz="1100" b="1" i="0" dirty="0">
+              <a:rPr sz="1100" b="0">
+                <a:solidFill>
+                  <a:srgbClr val="000000"/>
+                </a:solidFill>
+                <a:latin typeface="Arial"/>
+              </a:rPr>
+              <a:t>•  </a:t>
+            </a:r>
+            <a:r>
+              <a:rPr sz="1100" b="1">
                 <a:solidFill>
                   <a:srgbClr val="000000"/>
                 </a:solidFill>
@@ -22725,7 +22734,7 @@
               <a:t>Where will TU access AI-era talent</a:t>
             </a:r>
             <a:r>
-              <a:rPr sz="1100" b="0" i="0" dirty="0">
+              <a:rPr sz="1100" b="0">
                 <a:solidFill>
                   <a:srgbClr val="000000"/>
                 </a:solidFill>
@@ -22738,14 +22747,14 @@
       </p:sp>
       <p:sp>
         <p:nvSpPr>
-          <p:cNvPr id="89" name="TextBox 16"/>
+          <p:cNvPr id="91" name="TextBox 90"/>
           <p:cNvSpPr txBox="1"/>
           <p:nvPr/>
         </p:nvSpPr>
         <p:spPr>
           <a:xfrm>
-            <a:off x="5184980" y="5824728"/>
-            <a:ext cx="1143000" cy="548640"/>
+            <a:off x="5138928" y="5824728"/>
+            <a:ext cx="1078992" cy="548640"/>
           </a:xfrm>
           <a:prstGeom prst="rect">
             <a:avLst/>
@@ -22753,14 +22762,18 @@
           <a:noFill/>
         </p:spPr>
         <p:txBody>
-          <a:bodyPr wrap="square" lIns="0" tIns="0" rIns="0" bIns="0" anchor="t">
+          <a:bodyPr wrap="square" lIns="0" rIns="0" tIns="0" bIns="0">
             <a:spAutoFit/>
           </a:bodyPr>
           <a:lstStyle/>
           <a:p>
-            <a:pPr algn="l"/>
+            <a:pPr>
+              <a:lnSpc>
+                <a:spcPct val="100000"/>
+              </a:lnSpc>
+            </a:pPr>
             <a:r>
-              <a:rPr sz="1200" b="1" i="0" dirty="0">
+              <a:rPr sz="1100" b="1">
                 <a:solidFill>
                   <a:srgbClr val="2251FF"/>
                 </a:solidFill>
@@ -22773,46 +22786,33 @@
       </p:sp>
       <p:cxnSp>
         <p:nvCxnSpPr>
-          <p:cNvPr id="90" name="LineBasicImpact 54">
-            <a:extLst>
-              <a:ext uri="{FF2B5EF4-FFF2-40B4-BE49-F238E27FC236}">
-                <a16:creationId xmlns:a16="http://schemas.microsoft.com/office/drawing/2014/main" id="{1BAEDC8C-7A5B-6C3B-4369-6F78188BB1E8}"/>
-              </a:ext>
-            </a:extLst>
-          </p:cNvPr>
-          <p:cNvCxnSpPr>
-            <a:cxnSpLocks/>
-          </p:cNvCxnSpPr>
-          <p:nvPr>
-            <p:custDataLst>
-              <p:tags r:id="rId5"/>
-            </p:custDataLst>
-          </p:nvPr>
+          <p:cNvPr id="92" name="Connector 91"/>
+          <p:cNvCxnSpPr/>
+          <p:nvPr/>
         </p:nvCxnSpPr>
         <p:spPr>
           <a:xfrm>
-            <a:off x="6282545" y="5824728"/>
+            <a:off x="6281928" y="5824728"/>
             <a:ext cx="0" cy="594360"/>
           </a:xfrm>
-          <a:prstGeom prst="straightConnector1">
+          <a:prstGeom prst="line">
             <a:avLst/>
           </a:prstGeom>
-          <a:ln w="19050" cap="flat">
+          <a:ln w="19050">
             <a:solidFill>
-              <a:schemeClr val="accent3"/>
+              <a:srgbClr val="2251FF"/>
             </a:solidFill>
-            <a:miter lim="800000"/>
-            <a:tailEnd type="none"/>
           </a:ln>
+          <a:effectLst/>
         </p:spPr>
         <p:style>
-          <a:lnRef idx="1">
+          <a:lnRef idx="2">
             <a:schemeClr val="accent1"/>
           </a:lnRef>
           <a:fillRef idx="0">
             <a:schemeClr val="accent1"/>
           </a:fillRef>
-          <a:effectRef idx="0">
+          <a:effectRef idx="1">
             <a:schemeClr val="accent1"/>
           </a:effectRef>
           <a:fontRef idx="minor">
@@ -22822,16 +22822,14 @@
       </p:cxnSp>
       <p:sp>
         <p:nvSpPr>
-          <p:cNvPr id="91" name="TextBox 18"/>
-          <p:cNvSpPr txBox="1">
-            <a:spLocks/>
-          </p:cNvSpPr>
+          <p:cNvPr id="93" name="TextBox 92"/>
+          <p:cNvSpPr txBox="1"/>
           <p:nvPr/>
         </p:nvSpPr>
         <p:spPr>
           <a:xfrm>
-            <a:off x="6430956" y="5824728"/>
-            <a:ext cx="5203257" cy="365760"/>
+            <a:off x="6428232" y="5824728"/>
+            <a:ext cx="5202936" cy="365760"/>
           </a:xfrm>
           <a:prstGeom prst="rect">
             <a:avLst/>
@@ -22839,20 +22837,27 @@
           <a:noFill/>
         </p:spPr>
         <p:txBody>
-          <a:bodyPr wrap="square" lIns="0" tIns="0" rIns="0" bIns="0" anchor="t">
+          <a:bodyPr wrap="square" lIns="0" rIns="0" tIns="0" bIns="0">
             <a:spAutoFit/>
           </a:bodyPr>
           <a:lstStyle/>
           <a:p>
-            <a:pPr marL="171450" indent="-171450" algn="l">
+            <a:pPr marL="137160" indent="-137160">
               <a:lnSpc>
                 <a:spcPct val="100000"/>
               </a:lnSpc>
-              <a:buFont typeface="Arial" panose="020B0604020202020204" pitchFamily="34" charset="0"/>
-              <a:buChar char="•"/>
             </a:pPr>
             <a:r>
-              <a:rPr sz="1100" b="1" i="0" dirty="0">
+              <a:rPr sz="1100" b="0">
+                <a:solidFill>
+                  <a:srgbClr val="000000"/>
+                </a:solidFill>
+                <a:latin typeface="Arial"/>
+              </a:rPr>
+              <a:t>•  </a:t>
+            </a:r>
+            <a:r>
+              <a:rPr sz="1100" b="1">
                 <a:solidFill>
                   <a:srgbClr val="000000"/>
                 </a:solidFill>
@@ -22861,7 +22866,7 @@
               <a:t>What mindset and behavior shifts</a:t>
             </a:r>
             <a:r>
-              <a:rPr sz="1100" b="0" i="0" dirty="0">
+              <a:rPr sz="1100" b="0">
                 <a:solidFill>
                   <a:srgbClr val="000000"/>
                 </a:solidFill>
@@ -22874,16 +22879,14 @@
       </p:sp>
       <p:sp>
         <p:nvSpPr>
-          <p:cNvPr id="92" name="TextBox 18"/>
-          <p:cNvSpPr txBox="1">
-            <a:spLocks/>
-          </p:cNvSpPr>
+          <p:cNvPr id="94" name="TextBox 93"/>
+          <p:cNvSpPr txBox="1"/>
           <p:nvPr/>
         </p:nvSpPr>
         <p:spPr>
           <a:xfrm>
-            <a:off x="6430956" y="6227064"/>
-            <a:ext cx="5203257" cy="192024"/>
+            <a:off x="6428232" y="6227064"/>
+            <a:ext cx="5202936" cy="192024"/>
           </a:xfrm>
           <a:prstGeom prst="rect">
             <a:avLst/>
@@ -22891,20 +22894,27 @@
           <a:noFill/>
         </p:spPr>
         <p:txBody>
-          <a:bodyPr wrap="square" lIns="0" tIns="0" rIns="0" bIns="0" anchor="t">
+          <a:bodyPr wrap="square" lIns="0" rIns="0" tIns="0" bIns="0">
             <a:spAutoFit/>
           </a:bodyPr>
           <a:lstStyle/>
           <a:p>
-            <a:pPr marL="171450" indent="-171450" algn="l">
+            <a:pPr marL="137160" indent="-137160">
               <a:lnSpc>
                 <a:spcPct val="100000"/>
               </a:lnSpc>
-              <a:buFont typeface="Arial" panose="020B0604020202020204" pitchFamily="34" charset="0"/>
-              <a:buChar char="•"/>
             </a:pPr>
             <a:r>
-              <a:rPr sz="1100" b="1" i="0" dirty="0">
+              <a:rPr sz="1100" b="0">
+                <a:solidFill>
+                  <a:srgbClr val="000000"/>
+                </a:solidFill>
+                <a:latin typeface="Arial"/>
+              </a:rPr>
+              <a:t>•  </a:t>
+            </a:r>
+            <a:r>
+              <a:rPr sz="1100" b="1">
                 <a:solidFill>
                   <a:srgbClr val="000000"/>
                 </a:solidFill>
@@ -22913,7 +22923,7 @@
               <a:t>Does TU have the change capacity</a:t>
             </a:r>
             <a:r>
-              <a:rPr sz="1100" b="0" i="0" dirty="0">
+              <a:rPr sz="1100" b="0">
                 <a:solidFill>
                   <a:srgbClr val="000000"/>
                 </a:solidFill>

</xml_diff>

<commit_message>
Rewrite questions in the platform-proposal grammar: no em-dash splices
Co-Authored-By: Claude Fable 5 <noreply@anthropic.com>
Claude-Session: https://claude.ai/code/session_01A3Z3HHfQP1XqLkWjeuhpsJ
</commit_message>
<xml_diff>
--- a/proposal/20260721_TU_Three_Pager_vDraft.pptx
+++ b/proposal/20260721_TU_Three_Pager_vDraft.pptx
@@ -21272,7 +21272,7 @@
                   </a:solidFill>
                   <a:latin typeface="Arial"/>
                 </a:rPr>
-                <a:t> Which domains hold material value at stake — anchored in TU's strategic priorities and value pools?</a:t>
+                <a:t> Which domains hold material value at stake, anchored in TU's strategic priorities and value pools?</a:t>
               </a:r>
             </a:p>
           </p:txBody>
@@ -21385,7 +21385,7 @@
                   </a:solidFill>
                   <a:latin typeface="Arial"/>
                 </a:rPr>
-                <a:t>How does each domain operate today</a:t>
+                <a:t>How does each domain operate today?</a:t>
               </a:r>
               <a:r>
                 <a:rPr sz="1400" b="0" i="0">
@@ -21394,7 +21394,7 @@
                   </a:solidFill>
                   <a:latin typeface="Arial"/>
                 </a:rPr>
-                <a:t> — the operating and cost baseline, deep enough to size AI potential?</a:t>
+                <a:t> What operating and cost baseline is needed to size AI potential?</a:t>
               </a:r>
             </a:p>
           </p:txBody>
@@ -21516,7 +21516,7 @@
                   </a:solidFill>
                   <a:latin typeface="Arial"/>
                 </a:rPr>
-                <a:t> — revenue, cost, cost avoidance, risk — weighed against readiness and feasibility?</a:t>
+                <a:t> (e.g., revenue growth, cost reduction, cost avoidance, risk), and how does it weigh against readiness and feasibility?</a:t>
               </a:r>
             </a:p>
           </p:txBody>
@@ -21638,7 +21638,7 @@
                   </a:solidFill>
                   <a:latin typeface="Arial"/>
                 </a:rPr>
-                <a:t> — and which no-regret moves start now?</a:t>
+                <a:t>, and which no-regret moves should start now?</a:t>
               </a:r>
             </a:p>
           </p:txBody>
@@ -21760,7 +21760,7 @@
                   </a:solidFill>
                   <a:latin typeface="Arial"/>
                 </a:rPr>
-                <a:t> — with what owners, milestones, and enabling investments?</a:t>
+                <a:t>, and with what owners, milestones, and enabling investments?</a:t>
               </a:r>
             </a:p>
           </p:txBody>
@@ -22059,7 +22059,7 @@
                 </a:solidFill>
                 <a:latin typeface="Arial"/>
               </a:rPr>
-              <a:t> — and what value would optimal spans, layers, and leadership density unlock?</a:t>
+              <a:t> (i.e., optimal spans, layers, and leadership density), and what value would it unlock?</a:t>
             </a:r>
           </a:p>
         </p:txBody>
@@ -22191,7 +22191,7 @@
                 </a:solidFill>
                 <a:latin typeface="Arial"/>
               </a:rPr>
-              <a:t> — a central platform division (e.g., Atlassian, Salesforce) or federated services (e.g., AWS) — and which fits TU?</a:t>
+              <a:t> (e.g., a central platform division at Atlassian and Salesforce, federated services at AWS), and which is the right model for TU?</a:t>
             </a:r>
           </a:p>
         </p:txBody>
@@ -22239,7 +22239,7 @@
                 </a:solidFill>
                 <a:latin typeface="Arial"/>
               </a:rPr>
-              <a:t>What size and composition for the platform and product engineering teams</a:t>
+              <a:t>What should be the size and composition of the platform and product engineering teams?</a:t>
             </a:r>
             <a:r>
               <a:rPr sz="1100" b="0">
@@ -22248,7 +22248,7 @@
                 </a:solidFill>
                 <a:latin typeface="Arial"/>
               </a:rPr>
-              <a:t> — and where should key roles reside (e.g., Platform PM, Data Science / Analytics, UI/UX)?</a:t>
+              <a:t> Where should key roles reside (e.g., Platform PM, Data Science / Analytics, UI/UX)?</a:t>
             </a:r>
           </a:p>
         </p:txBody>
@@ -22305,7 +22305,7 @@
                 </a:solidFill>
                 <a:latin typeface="Arial"/>
               </a:rPr>
-              <a:t> — US vs. international P&amp;L, regional vs. global layers — and what must TU believe?</a:t>
+              <a:t> (e.g., US vs. international P&amp;L, regional vs. global layers), and what must TU believe?</a:t>
             </a:r>
           </a:p>
         </p:txBody>
@@ -22485,7 +22485,7 @@
                 </a:solidFill>
                 <a:latin typeface="Arial"/>
               </a:rPr>
-              <a:t>What size, shape, and skills</a:t>
+              <a:t>What size, shape, and skills will the workforce need?</a:t>
             </a:r>
             <a:r>
               <a:rPr sz="1100" b="0">
@@ -22494,7 +22494,7 @@
                 </a:solidFill>
                 <a:latin typeface="Arial"/>
               </a:rPr>
-              <a:t> — which roles are reshaped, replaced, or net-new; built vs. bought?</a:t>
+              <a:t> Which roles are reshaped, replaced, or net-new; built vs. bought?</a:t>
             </a:r>
           </a:p>
         </p:txBody>
@@ -22551,7 +22551,7 @@
                 </a:solidFill>
                 <a:latin typeface="Arial"/>
               </a:rPr>
-              <a:t> — and the mobilization plan to capture it?</a:t>
+              <a:t>, and the mobilization plan to capture it?</a:t>
             </a:r>
           </a:p>
         </p:txBody>
@@ -22683,7 +22683,7 @@
                 </a:solidFill>
                 <a:latin typeface="Arial"/>
               </a:rPr>
-              <a:t> — and what moves now vs. later?</a:t>
+              <a:t>, and what moves now vs. later?</a:t>
             </a:r>
           </a:p>
         </p:txBody>
@@ -22740,7 +22740,7 @@
                 </a:solidFill>
                 <a:latin typeface="Arial"/>
               </a:rPr>
-              <a:t> — and what must its global hubs become?</a:t>
+              <a:t>, and what must its global hubs become?</a:t>
             </a:r>
           </a:p>
         </p:txBody>
@@ -22929,7 +22929,7 @@
                 </a:solidFill>
                 <a:latin typeface="Arial"/>
               </a:rPr>
-              <a:t> — and how do we build it?</a:t>
+              <a:t>, and how do we build it?</a:t>
             </a:r>
           </a:p>
         </p:txBody>

</xml_diff>

<commit_message>
Three platform archetypes in question B1; value case moved to closing F bucket
Co-Authored-By: Claude Fable 5 <noreply@anthropic.com>
Claude-Session: https://claude.ai/code/session_01A3Z3HHfQP1XqLkWjeuhpsJ
</commit_message>
<xml_diff>
--- a/proposal/20260721_TU_Three_Pager_vDraft.pptx
+++ b/proposal/20260721_TU_Three_Pager_vDraft.pptx
@@ -22191,7 +22191,7 @@
                 </a:solidFill>
                 <a:latin typeface="Arial"/>
               </a:rPr>
-              <a:t> (e.g., a central platform division at Atlassian and Salesforce, federated services at AWS), and which is the right model for TU?</a:t>
+              <a:t> (e.g., one unified platform at Stripe, a central platform division at Atlassian and Salesforce, federated services at AWS), and which fits TU?</a:t>
             </a:r>
           </a:p>
         </p:txBody>
@@ -22358,7 +22358,7 @@
         <p:spPr>
           <a:xfrm>
             <a:off x="6281928" y="3977639"/>
-            <a:ext cx="0" cy="1033273"/>
+            <a:ext cx="0" cy="786384"/>
           </a:xfrm>
           <a:prstGeom prst="line">
             <a:avLst/>
@@ -22501,70 +22501,13 @@
       </p:sp>
       <p:sp>
         <p:nvSpPr>
-          <p:cNvPr id="86" name="TextBox 85"/>
-          <p:cNvSpPr txBox="1"/>
-          <p:nvPr/>
-        </p:nvSpPr>
-        <p:spPr>
-          <a:xfrm>
-            <a:off x="6428232" y="4818888"/>
-            <a:ext cx="5202936" cy="192024"/>
-          </a:xfrm>
-          <a:prstGeom prst="rect">
-            <a:avLst/>
-          </a:prstGeom>
-          <a:noFill/>
-        </p:spPr>
-        <p:txBody>
-          <a:bodyPr wrap="square" lIns="0" rIns="0" tIns="0" bIns="0">
-            <a:spAutoFit/>
-          </a:bodyPr>
-          <a:lstStyle/>
-          <a:p>
-            <a:pPr marL="137160" indent="-137160">
-              <a:lnSpc>
-                <a:spcPct val="100000"/>
-              </a:lnSpc>
-            </a:pPr>
-            <a:r>
-              <a:rPr sz="1100" b="0">
-                <a:solidFill>
-                  <a:srgbClr val="000000"/>
-                </a:solidFill>
-                <a:latin typeface="Arial"/>
-              </a:rPr>
-              <a:t>•  </a:t>
-            </a:r>
-            <a:r>
-              <a:rPr sz="1100" b="1">
-                <a:solidFill>
-                  <a:srgbClr val="000000"/>
-                </a:solidFill>
-                <a:latin typeface="Arial"/>
-              </a:rPr>
-              <a:t>What is the value case</a:t>
-            </a:r>
-            <a:r>
-              <a:rPr sz="1100" b="0">
-                <a:solidFill>
-                  <a:srgbClr val="000000"/>
-                </a:solidFill>
-                <a:latin typeface="Arial"/>
-              </a:rPr>
-              <a:t>, and the mobilization plan to capture it?</a:t>
-            </a:r>
-          </a:p>
-        </p:txBody>
-      </p:sp>
-      <p:sp>
-        <p:nvSpPr>
           <p:cNvPr id="87" name="TextBox 86"/>
           <p:cNvSpPr txBox="1"/>
           <p:nvPr/>
         </p:nvSpPr>
         <p:spPr>
           <a:xfrm>
-            <a:off x="5138928" y="5138928"/>
+            <a:off x="5138928" y="4855464"/>
             <a:ext cx="1078992" cy="777240"/>
           </a:xfrm>
           <a:prstGeom prst="rect">
@@ -22603,7 +22546,7 @@
         </p:nvCxnSpPr>
         <p:spPr>
           <a:xfrm>
-            <a:off x="6281928" y="5138928"/>
+            <a:off x="6281928" y="4855464"/>
             <a:ext cx="0" cy="612648"/>
           </a:xfrm>
           <a:prstGeom prst="line">
@@ -22639,7 +22582,7 @@
         </p:nvSpPr>
         <p:spPr>
           <a:xfrm>
-            <a:off x="6428232" y="5138928"/>
+            <a:off x="6428232" y="4855464"/>
             <a:ext cx="5202936" cy="192024"/>
           </a:xfrm>
           <a:prstGeom prst="rect">
@@ -22696,7 +22639,7 @@
         </p:nvSpPr>
         <p:spPr>
           <a:xfrm>
-            <a:off x="6428232" y="5385816"/>
+            <a:off x="6428232" y="5102352"/>
             <a:ext cx="5202936" cy="365760"/>
           </a:xfrm>
           <a:prstGeom prst="rect">
@@ -22753,7 +22696,7 @@
         </p:nvSpPr>
         <p:spPr>
           <a:xfrm>
-            <a:off x="5138928" y="5824728"/>
+            <a:off x="5138928" y="5559552"/>
             <a:ext cx="1078992" cy="548640"/>
           </a:xfrm>
           <a:prstGeom prst="rect">
@@ -22792,7 +22735,7 @@
         </p:nvCxnSpPr>
         <p:spPr>
           <a:xfrm>
-            <a:off x="6281928" y="5824728"/>
+            <a:off x="6281928" y="5559552"/>
             <a:ext cx="0" cy="594360"/>
           </a:xfrm>
           <a:prstGeom prst="line">
@@ -22828,7 +22771,7 @@
         </p:nvSpPr>
         <p:spPr>
           <a:xfrm>
-            <a:off x="6428232" y="5824728"/>
+            <a:off x="6428232" y="5559552"/>
             <a:ext cx="5202936" cy="365760"/>
           </a:xfrm>
           <a:prstGeom prst="rect">
@@ -22885,7 +22828,7 @@
         </p:nvSpPr>
         <p:spPr>
           <a:xfrm>
-            <a:off x="6428232" y="6227064"/>
+            <a:off x="6428232" y="5980176"/>
             <a:ext cx="5202936" cy="192024"/>
           </a:xfrm>
           <a:prstGeom prst="rect">
@@ -22930,6 +22873,138 @@
                 <a:latin typeface="Arial"/>
               </a:rPr>
               <a:t>, and how do we build it?</a:t>
+            </a:r>
+          </a:p>
+        </p:txBody>
+      </p:sp>
+      <p:sp>
+        <p:nvSpPr>
+          <p:cNvPr id="95" name="TextBox 94"/>
+          <p:cNvSpPr txBox="1"/>
+          <p:nvPr/>
+        </p:nvSpPr>
+        <p:spPr>
+          <a:xfrm>
+            <a:off x="5138928" y="6254496"/>
+            <a:ext cx="1078992" cy="365760"/>
+          </a:xfrm>
+          <a:prstGeom prst="rect">
+            <a:avLst/>
+          </a:prstGeom>
+          <a:noFill/>
+        </p:spPr>
+        <p:txBody>
+          <a:bodyPr wrap="square" lIns="0" rIns="0" tIns="0" bIns="0">
+            <a:spAutoFit/>
+          </a:bodyPr>
+          <a:lstStyle/>
+          <a:p>
+            <a:pPr>
+              <a:lnSpc>
+                <a:spcPct val="100000"/>
+              </a:lnSpc>
+            </a:pPr>
+            <a:r>
+              <a:rPr sz="1100" b="1">
+                <a:solidFill>
+                  <a:srgbClr val="2251FF"/>
+                </a:solidFill>
+                <a:latin typeface="Arial"/>
+              </a:rPr>
+              <a:t>F. VALUE CASE</a:t>
+            </a:r>
+          </a:p>
+        </p:txBody>
+      </p:sp>
+      <p:cxnSp>
+        <p:nvCxnSpPr>
+          <p:cNvPr id="96" name="Connector 95"/>
+          <p:cNvCxnSpPr/>
+          <p:nvPr/>
+        </p:nvCxnSpPr>
+        <p:spPr>
+          <a:xfrm>
+            <a:off x="6281928" y="6254496"/>
+            <a:ext cx="0" cy="192024"/>
+          </a:xfrm>
+          <a:prstGeom prst="line">
+            <a:avLst/>
+          </a:prstGeom>
+          <a:ln w="19050">
+            <a:solidFill>
+              <a:srgbClr val="2251FF"/>
+            </a:solidFill>
+          </a:ln>
+          <a:effectLst/>
+        </p:spPr>
+        <p:style>
+          <a:lnRef idx="2">
+            <a:schemeClr val="accent1"/>
+          </a:lnRef>
+          <a:fillRef idx="0">
+            <a:schemeClr val="accent1"/>
+          </a:fillRef>
+          <a:effectRef idx="1">
+            <a:schemeClr val="accent1"/>
+          </a:effectRef>
+          <a:fontRef idx="minor">
+            <a:schemeClr val="tx1"/>
+          </a:fontRef>
+        </p:style>
+      </p:cxnSp>
+      <p:sp>
+        <p:nvSpPr>
+          <p:cNvPr id="97" name="TextBox 96"/>
+          <p:cNvSpPr txBox="1"/>
+          <p:nvPr/>
+        </p:nvSpPr>
+        <p:spPr>
+          <a:xfrm>
+            <a:off x="6428232" y="6254496"/>
+            <a:ext cx="5202936" cy="192024"/>
+          </a:xfrm>
+          <a:prstGeom prst="rect">
+            <a:avLst/>
+          </a:prstGeom>
+          <a:noFill/>
+        </p:spPr>
+        <p:txBody>
+          <a:bodyPr wrap="square" lIns="0" rIns="0" tIns="0" bIns="0">
+            <a:spAutoFit/>
+          </a:bodyPr>
+          <a:lstStyle/>
+          <a:p>
+            <a:pPr marL="137160" indent="-137160">
+              <a:lnSpc>
+                <a:spcPct val="100000"/>
+              </a:lnSpc>
+            </a:pPr>
+            <a:r>
+              <a:rPr sz="1100" b="0">
+                <a:solidFill>
+                  <a:srgbClr val="000000"/>
+                </a:solidFill>
+                <a:latin typeface="Arial"/>
+              </a:rPr>
+              <a:t>•  </a:t>
+            </a:r>
+            <a:r>
+              <a:rPr sz="1100" b="1">
+                <a:solidFill>
+                  <a:srgbClr val="000000"/>
+                </a:solidFill>
+                <a:latin typeface="Arial"/>
+              </a:rPr>
+              <a:t>What is the complete value case</a:t>
+            </a:r>
+            <a:r>
+              <a:rPr sz="1100" b="0">
+                <a:solidFill>
+                  <a:srgbClr val="000000"/>
+                </a:solidFill>
+                <a:latin typeface="Arial"/>
+              </a:rPr>
+              <a:t>, and the 90-day plan to mobilize?</a:t>
             </a:r>
           </a:p>
         </p:txBody>

</xml_diff>